<commit_message>
Form 1: revise all 22 lessons to the validated model
Board summary follows the syllabus points in order, definitions apart, one
element per slide with its picture, at least three or four items per list;
situations state the problem as a question; one question per activity
slide. New diagrams: globe, map projections, land and water shares.
References and credits now include photos used in the board summary.

Co-Authored-By: Claude Opus 5.5 <noreply@anthropic.com>
Claude-Session: https://claude.ai/code/session_0115LFSb2ktGLWPeVksFkSer
</commit_message>
<xml_diff>
--- a/lecons/F1/06_F1_M1_PW03_Calculation_of_Time.pptx
+++ b/lecons/F1/06_F1_M1_PW03_Calculation_of_Time.pptx
@@ -58,9 +58,12 @@
     <p:sldId id="306" r:id="rId52"/>
     <p:sldId id="307" r:id="rId53"/>
     <p:sldId id="308" r:id="rId54"/>
+    <p:sldId id="309" r:id="rId55"/>
+    <p:sldId id="310" r:id="rId56"/>
+    <p:sldId id="311" r:id="rId57"/>
   </p:sldIdLst>
   <p:notesMasterIdLst>
-    <p:notesMasterId r:id="rId55"/>
+    <p:notesMasterId r:id="rId58"/>
   </p:notesMasterIdLst>
   <p:sldSz cx="12192000" cy="6858000"/>
   <p:notesSz cx="6858000" cy="12192000"/>
@@ -642,7 +645,7 @@
           <a:p>
             <a:r>
               <a:rPr lang="en-US" dirty="0"/>
-              <a:t>Listen carefully to this situation from real life. A football match starts at 20:00 in Paris. Moussa wants to watch it on television in Garoua, but he does not know at what time it will start in Cameroon. Think about it, because I am going to ask you some questions.</a:t>
+              <a:t>Listen carefully to this situation from real life. A football match starts at 18:00 in London. Moussa wants to watch it on television in Garoua. He asks his friends: "At what time will the match start in Cameroon?" None of them can calculate it. Think about it, because I am going to ask you some questions.</a:t>
             </a:r>
             <a:endParaRPr lang="en-US" dirty="0"/>
           </a:p>
@@ -818,7 +821,7 @@
           <a:p>
             <a:r>
               <a:rPr lang="en-US" dirty="0"/>
-              <a:t>Good. Moussa does not know the time of the match in Cameroon.</a:t>
+              <a:t>Good. Moussa and his friends do not know how to calculate the time of the match in Cameroon.</a:t>
             </a:r>
             <a:endParaRPr lang="en-US" dirty="0"/>
           </a:p>
@@ -994,7 +997,7 @@
           <a:p>
             <a:r>
               <a:rPr lang="en-US" dirty="0"/>
-              <a:t>Good. The time difference between Paris and Cameroon.</a:t>
+              <a:t>Good. The time difference between London and Cameroon.</a:t>
             </a:r>
             <a:endParaRPr lang="en-US" dirty="0"/>
           </a:p>
@@ -1170,7 +1173,7 @@
           <a:p>
             <a:r>
               <a:rPr lang="en-US" dirty="0"/>
-              <a:t>Good. By using the time zones or the longitudes.</a:t>
+              <a:t>Good. By using the longitudes or the time zones.</a:t>
             </a:r>
             <a:endParaRPr lang="en-US" dirty="0"/>
           </a:p>
@@ -1698,7 +1701,7 @@
           <a:p>
             <a:r>
               <a:rPr lang="en-US" dirty="0"/>
-              <a:t>Let us check the answer together. 360 ÷ 24 = 15° per hour, so 1° = 4 minutes.</a:t>
+              <a:t>Let us check the answer together. 360 ÷ 24 = 15° per hour, so 1° takes 4 minutes.</a:t>
             </a:r>
             <a:endParaRPr lang="en-US" dirty="0"/>
           </a:p>
@@ -1962,7 +1965,7 @@
           <a:p>
             <a:r>
               <a:rPr lang="en-US" dirty="0"/>
-              <a:t>Let us check the answer together. 30 × 4 min = 120 min = 2 hours; the place is east, so 12:00 + 2 h = 14:00.</a:t>
+              <a:t>Let us check the answer together. 30 × 4 min = 120 min = 2 hours; the place is to the east, so 12:00 + 2 h = 14:00.</a:t>
             </a:r>
             <a:endParaRPr lang="en-US" dirty="0"/>
           </a:p>
@@ -2226,7 +2229,7 @@
           <a:p>
             <a:r>
               <a:rPr lang="en-US" dirty="0"/>
-              <a:t>Let us check the answer together. 45 × 4 = 180 min = 3 hours; the place is west, so 10:00 − 3 h = 07:00.</a:t>
+              <a:t>Let us check the answer together. 45 × 4 = 180 min = 3 hours; the place is to the west, so 10:00 − 3 h = 07:00.</a:t>
             </a:r>
             <a:endParaRPr lang="en-US" dirty="0"/>
           </a:p>
@@ -2578,7 +2581,7 @@
           <a:p>
             <a:r>
               <a:rPr lang="en-US" dirty="0"/>
-              <a:t>Let us check the answer together. To avoid a different time in every town; each zone of about 15° uses the same standard time.</a:t>
+              <a:t>Let us check the answer together. To avoid a different time in every town: each zone of about 15° uses the same standard time.</a:t>
             </a:r>
             <a:endParaRPr lang="en-US" dirty="0"/>
           </a:p>
@@ -2754,7 +2757,7 @@
           <a:p>
             <a:r>
               <a:rPr lang="en-US" dirty="0"/>
-              <a:t>Here is the question for Activity 5: Cameroon uses GMT + 1. When it is 12:00 in Garoua, what time is it in London (GMT) and in Dubai (GMT + 4)? Take one minute to think and write your answer in your rough notebook.</a:t>
+              <a:t>Here is the question for Activity 5: When it is 12:00 in Garoua (GMT + 1), what time is it in London (GMT)? Take one minute to think and write your answer in your rough notebook.</a:t>
             </a:r>
             <a:endParaRPr lang="en-US" dirty="0"/>
           </a:p>
@@ -2842,7 +2845,7 @@
           <a:p>
             <a:r>
               <a:rPr lang="en-US" dirty="0"/>
-              <a:t>Let us check the answer together. London: 11:00. Dubai: 15:00.</a:t>
+              <a:t>Let us check the answer together. 11:00.</a:t>
             </a:r>
             <a:endParaRPr lang="en-US" dirty="0"/>
           </a:p>
@@ -3194,7 +3197,7 @@
           <a:p>
             <a:r>
               <a:rPr lang="en-US" dirty="0"/>
-              <a:t>Let us copy Rules for Calculating Time. We calculate time with the following rules. On this slide we have Rule 1 and Rule 2. Write each point on a new line, with the key term first, and explain it in your own words when we revise. When you finish, we go to the next slide.</a:t>
+              <a:t>Let us copy Rules for Calculating Local Time. We calculate local time with the following rules. Copy the point on Rule 1 on the left, then draw the diagram on the right: time and longitude. Give it a title and label it clearly.</a:t>
             </a:r>
             <a:endParaRPr lang="en-US" dirty="0"/>
           </a:p>
@@ -3282,7 +3285,7 @@
           <a:p>
             <a:r>
               <a:rPr lang="en-US" dirty="0"/>
-              <a:t>We continue with Rules for Calculating Time. On this slide we have Rule 3. Write each point on a new line, with the key term first, and explain it in your own words when we revise.</a:t>
+              <a:t>We continue with Rules for Calculating Local Time. On this slide we have Rule 2 and Rule 3. Write each point on a new line, with the key term first, and explain it in your own words when we revise.</a:t>
             </a:r>
             <a:endParaRPr lang="en-US" dirty="0"/>
           </a:p>
@@ -3370,7 +3373,7 @@
           <a:p>
             <a:r>
               <a:rPr lang="en-US" dirty="0"/>
-              <a:t>Now draw this illustration in your notebook: calculating local time. Give it a title and label it clearly.</a:t>
+              <a:t>Let us copy Calculating Local Time from GMT. We calculate local time from GMT as in the following examples. Copy the point on Example to the east on the left, then draw the diagram on the right: calculating local time. Give it a title and label it clearly.</a:t>
             </a:r>
             <a:endParaRPr lang="en-US" dirty="0"/>
           </a:p>
@@ -3546,7 +3549,7 @@
           <a:p>
             <a:r>
               <a:rPr lang="en-US" dirty="0"/>
-              <a:t>Let us copy Time Zones and Cameroon's Standard Time. Time zones are organised as follows. On this slide we have Basis of time zones and Cameroon. Write each point on a new line, with the key term first, and explain it in your own words when we revise. When you finish, we go to the next slide.</a:t>
+              <a:t>We continue with Calculating Local Time from GMT. On this slide we have Example to the west. Write each point on a new line, with the key term first, and explain it in your own words when we revise.</a:t>
             </a:r>
             <a:endParaRPr lang="en-US" dirty="0"/>
           </a:p>
@@ -3634,7 +3637,7 @@
           <a:p>
             <a:r>
               <a:rPr lang="en-US" dirty="0"/>
-              <a:t>We continue with Time Zones and Cameroon's Standard Time. On this slide we have Comparison. Write each point on a new line, with the key term first, and explain it in your own words when we revise.</a:t>
+              <a:t>Let us copy Basis of Time Zones. Time zones are carved out as follows. Copy the point on 24 time zones on the left, then draw the diagram on the right: time zones of the world. Give it a title and label it clearly.</a:t>
             </a:r>
             <a:endParaRPr lang="en-US" dirty="0"/>
           </a:p>
@@ -3722,7 +3725,7 @@
           <a:p>
             <a:r>
               <a:rPr lang="en-US" dirty="0"/>
-              <a:t>Now let us check what you have understood. Question 1: It is 08:00 GMT. What is the local time at 60° E? Answer in your exercise book.</a:t>
+              <a:t>We continue with Basis of Time Zones. On this slide we have Standard time and Boundaries. Write each point on a new line, with the key term first, and explain it in your own words when we revise.</a:t>
             </a:r>
             <a:endParaRPr lang="en-US" dirty="0"/>
           </a:p>
@@ -3810,7 +3813,7 @@
           <a:p>
             <a:r>
               <a:rPr lang="en-US" dirty="0"/>
-              <a:t>The expected answer is: 60 × 4 = 240 min = 4 h; 08:00 + 4 h = 12:00. If you got it right, well done.</a:t>
+              <a:t>Let us copy Cameroon's Standard Time and Other Areas. When it is 12:00 in Cameroon (GMT + 1), the time elsewhere is the following. Copy the point on London (GMT) on the left, then draw the diagram on the right: clocks in different cities. Give it a title and label it clearly.</a:t>
             </a:r>
             <a:endParaRPr lang="en-US" dirty="0"/>
           </a:p>
@@ -3898,7 +3901,7 @@
           <a:p>
             <a:r>
               <a:rPr lang="en-US" dirty="0"/>
-              <a:t>Now let us check what you have understood. Question 2: A match starts at 20:00 in Paris (GMT + 1). What time is it in Cameroon? Answer in your exercise book.</a:t>
+              <a:t>We continue with Cameroon's Standard Time and Other Areas. On this slide we have Nigeria and Chad (GMT + 1), Dubai (GMT + 4) and New York (GMT − 5). Write each point on a new line, with the key term first, and explain it in your own words when we revise.</a:t>
             </a:r>
             <a:endParaRPr lang="en-US" dirty="0"/>
           </a:p>
@@ -3986,7 +3989,7 @@
           <a:p>
             <a:r>
               <a:rPr lang="en-US" dirty="0"/>
-              <a:t>The expected answer is: 20:00, because both use GMT + 1. If you got it right, well done.</a:t>
+              <a:t>Now let us check what you have understood. Question 1: It is 08:00 GMT. What is the local time at 60° E? Answer in your exercise book.</a:t>
             </a:r>
             <a:endParaRPr lang="en-US" dirty="0"/>
           </a:p>
@@ -4074,7 +4077,7 @@
           <a:p>
             <a:r>
               <a:rPr lang="en-US" dirty="0"/>
-              <a:t>For those who need more practice, fill in the blanks in your exercise book. The answers are: number 1, 15; number 2, 4; number 3, east.</a:t>
+              <a:t>The expected answer is: 60 × 4 = 240 min = 4 h; 08:00 + 4 h = 12:00. If you got it right, well done.</a:t>
             </a:r>
             <a:endParaRPr lang="en-US" dirty="0"/>
           </a:p>
@@ -4162,7 +4165,7 @@
           <a:p>
             <a:r>
               <a:rPr lang="en-US" dirty="0"/>
-              <a:t>For your homework: When it is 09:00 in Garoua (GMT + 1), what time is it in New York (GMT − 5)? We shall correct it at the beginning of our next lesson.</a:t>
+              <a:t>Now let us check what you have understood. Question 2: A match starts at 18:00 in London (GMT). What time is it in Cameroon? Answer in your exercise book.</a:t>
             </a:r>
             <a:endParaRPr lang="en-US" dirty="0"/>
           </a:p>
@@ -4250,7 +4253,7 @@
           <a:p>
             <a:r>
               <a:rPr lang="en-US" dirty="0"/>
-              <a:t>Our next lesson will be on Lesson 4: The Notion of the Environment. Thank you for your attention, and see you next time.</a:t>
+              <a:t>The expected answer is: 19:00, because Cameroon is GMT + 1. If you got it right, well done.</a:t>
             </a:r>
             <a:endParaRPr lang="en-US" dirty="0"/>
           </a:p>
@@ -4338,7 +4341,7 @@
           <a:p>
             <a:r>
               <a:rPr lang="en-US" dirty="0"/>
-              <a:t>Let us play the bilingual game. I say a word in English, and you give me the French word. Then we do the reverse.</a:t>
+              <a:t>For those who need more practice, fill in the blanks in your exercise book. The answers are: number 1, 15; number 2, 4; number 3, east.</a:t>
             </a:r>
             <a:endParaRPr lang="en-US" dirty="0"/>
           </a:p>
@@ -4514,7 +4517,7 @@
           <a:p>
             <a:r>
               <a:rPr lang="en-US" dirty="0"/>
-              <a:t>I record this information in the official logbook of the class after the lesson.</a:t>
+              <a:t>For your homework: When it is 09:00 in Garoua (GMT + 1), what time is it in New York (GMT − 5)? We shall correct it at the beginning of our next lesson.</a:t>
             </a:r>
             <a:endParaRPr lang="en-US" dirty="0"/>
           </a:p>
@@ -4602,7 +4605,7 @@
           <a:p>
             <a:r>
               <a:rPr lang="en-US" dirty="0"/>
-              <a:t>I complete the second page of the logbook: the matter taught, the evaluation, the homework and the attendance.</a:t>
+              <a:t>Our next lesson will be on Lesson 4: The Notion of the Environment. Thank you for your attention, and see you next time.</a:t>
             </a:r>
             <a:endParaRPr lang="en-US" dirty="0"/>
           </a:p>
@@ -4690,7 +4693,7 @@
           <a:p>
             <a:r>
               <a:rPr lang="en-US" dirty="0"/>
-              <a:t>This slide is for me, the teacher: it gives the timing of the lesson and what to do if the projector is not available.</a:t>
+              <a:t>Let us play the bilingual game. I say a word in English, and you give me the French word. Then we do the reverse.</a:t>
             </a:r>
             <a:endParaRPr lang="en-US" dirty="0"/>
           </a:p>
@@ -4778,7 +4781,7 @@
           <a:p>
             <a:r>
               <a:rPr lang="en-US" dirty="0"/>
-              <a:t>These are the references and picture credits used to prepare this lesson.</a:t>
+              <a:t>I record this information in the official logbook of the class after the lesson.</a:t>
             </a:r>
             <a:endParaRPr lang="en-US" dirty="0"/>
           </a:p>
@@ -4802,6 +4805,270 @@
             <a:fld id="{F7021451-1387-4CA6-816F-3879F97B5CBC}" type="slidenum">
               <a:rPr lang="en-US"/>
               <a:t>53</a:t>
+            </a:fld>
+            <a:endParaRPr lang="en-US"/>
+          </a:p>
+        </p:txBody>
+      </p:sp>
+    </p:spTree>
+    <p:extLst>
+      <p:ext uri="{BB962C8B-B14F-4D97-AF65-F5344CB8AC3E}">
+        <p14:creationId xmlns:p14="http://schemas.microsoft.com/office/powerpoint/2010/main" val="1024086991"/>
+      </p:ext>
+    </p:extLst>
+  </p:cSld>
+  <p:clrMapOvr>
+    <a:masterClrMapping/>
+  </p:clrMapOvr>
+</p:notes>
+</file>
+
+<file path=ppt/notesSlides/notesSlide54.xml><?xml version="1.0" encoding="utf-8"?>
+<p:notes xmlns:a="http://schemas.openxmlformats.org/drawingml/2006/main" xmlns:r="http://schemas.openxmlformats.org/officeDocument/2006/relationships" xmlns:p="http://schemas.openxmlformats.org/presentationml/2006/main">
+  <p:cSld>
+    <p:spTree>
+      <p:nvGrpSpPr>
+        <p:cNvPr id="1" name=""/>
+        <p:cNvGrpSpPr/>
+        <p:nvPr/>
+      </p:nvGrpSpPr>
+      <p:grpSpPr>
+        <a:xfrm>
+          <a:off x="0" y="0"/>
+          <a:ext cx="0" cy="0"/>
+          <a:chOff x="0" y="0"/>
+          <a:chExt cx="0" cy="0"/>
+        </a:xfrm>
+      </p:grpSpPr>
+      <p:sp>
+        <p:nvSpPr>
+          <p:cNvPr id="2" name="Slide Image Placeholder 1"/>
+          <p:cNvSpPr>
+            <a:spLocks noGrp="1" noRot="1" noChangeAspect="1"/>
+          </p:cNvSpPr>
+          <p:nvPr>
+            <p:ph type="sldImg"/>
+          </p:nvPr>
+        </p:nvSpPr>
+        <p:spPr/>
+      </p:sp>
+      <p:sp>
+        <p:nvSpPr>
+          <p:cNvPr id="3" name="Notes Placeholder 2"/>
+          <p:cNvSpPr>
+            <a:spLocks noGrp="1"/>
+          </p:cNvSpPr>
+          <p:nvPr>
+            <p:ph type="body" idx="1"/>
+          </p:nvPr>
+        </p:nvSpPr>
+        <p:spPr/>
+        <p:txBody>
+          <a:bodyPr/>
+          <a:lstStyle/>
+          <a:p>
+            <a:r>
+              <a:rPr lang="en-US" dirty="0"/>
+              <a:t>I complete the second page of the logbook: the matter taught, the evaluation, the homework and the attendance.</a:t>
+            </a:r>
+            <a:endParaRPr lang="en-US" dirty="0"/>
+          </a:p>
+        </p:txBody>
+      </p:sp>
+      <p:sp>
+        <p:nvSpPr>
+          <p:cNvPr id="4" name="Slide Number Placeholder 3"/>
+          <p:cNvSpPr>
+            <a:spLocks noGrp="1"/>
+          </p:cNvSpPr>
+          <p:nvPr>
+            <p:ph type="sldNum" sz="quarter" idx="10"/>
+          </p:nvPr>
+        </p:nvSpPr>
+        <p:spPr/>
+        <p:txBody>
+          <a:bodyPr/>
+          <a:lstStyle/>
+          <a:p>
+            <a:fld id="{F7021451-1387-4CA6-816F-3879F97B5CBC}" type="slidenum">
+              <a:rPr lang="en-US"/>
+              <a:t>54</a:t>
+            </a:fld>
+            <a:endParaRPr lang="en-US"/>
+          </a:p>
+        </p:txBody>
+      </p:sp>
+    </p:spTree>
+    <p:extLst>
+      <p:ext uri="{BB962C8B-B14F-4D97-AF65-F5344CB8AC3E}">
+        <p14:creationId xmlns:p14="http://schemas.microsoft.com/office/powerpoint/2010/main" val="1024086991"/>
+      </p:ext>
+    </p:extLst>
+  </p:cSld>
+  <p:clrMapOvr>
+    <a:masterClrMapping/>
+  </p:clrMapOvr>
+</p:notes>
+</file>
+
+<file path=ppt/notesSlides/notesSlide55.xml><?xml version="1.0" encoding="utf-8"?>
+<p:notes xmlns:a="http://schemas.openxmlformats.org/drawingml/2006/main" xmlns:r="http://schemas.openxmlformats.org/officeDocument/2006/relationships" xmlns:p="http://schemas.openxmlformats.org/presentationml/2006/main">
+  <p:cSld>
+    <p:spTree>
+      <p:nvGrpSpPr>
+        <p:cNvPr id="1" name=""/>
+        <p:cNvGrpSpPr/>
+        <p:nvPr/>
+      </p:nvGrpSpPr>
+      <p:grpSpPr>
+        <a:xfrm>
+          <a:off x="0" y="0"/>
+          <a:ext cx="0" cy="0"/>
+          <a:chOff x="0" y="0"/>
+          <a:chExt cx="0" cy="0"/>
+        </a:xfrm>
+      </p:grpSpPr>
+      <p:sp>
+        <p:nvSpPr>
+          <p:cNvPr id="2" name="Slide Image Placeholder 1"/>
+          <p:cNvSpPr>
+            <a:spLocks noGrp="1" noRot="1" noChangeAspect="1"/>
+          </p:cNvSpPr>
+          <p:nvPr>
+            <p:ph type="sldImg"/>
+          </p:nvPr>
+        </p:nvSpPr>
+        <p:spPr/>
+      </p:sp>
+      <p:sp>
+        <p:nvSpPr>
+          <p:cNvPr id="3" name="Notes Placeholder 2"/>
+          <p:cNvSpPr>
+            <a:spLocks noGrp="1"/>
+          </p:cNvSpPr>
+          <p:nvPr>
+            <p:ph type="body" idx="1"/>
+          </p:nvPr>
+        </p:nvSpPr>
+        <p:spPr/>
+        <p:txBody>
+          <a:bodyPr/>
+          <a:lstStyle/>
+          <a:p>
+            <a:r>
+              <a:rPr lang="en-US" dirty="0"/>
+              <a:t>This slide is for me, the teacher: it gives the timing of the lesson and what to do if the projector is not available.</a:t>
+            </a:r>
+            <a:endParaRPr lang="en-US" dirty="0"/>
+          </a:p>
+        </p:txBody>
+      </p:sp>
+      <p:sp>
+        <p:nvSpPr>
+          <p:cNvPr id="4" name="Slide Number Placeholder 3"/>
+          <p:cNvSpPr>
+            <a:spLocks noGrp="1"/>
+          </p:cNvSpPr>
+          <p:nvPr>
+            <p:ph type="sldNum" sz="quarter" idx="10"/>
+          </p:nvPr>
+        </p:nvSpPr>
+        <p:spPr/>
+        <p:txBody>
+          <a:bodyPr/>
+          <a:lstStyle/>
+          <a:p>
+            <a:fld id="{F7021451-1387-4CA6-816F-3879F97B5CBC}" type="slidenum">
+              <a:rPr lang="en-US"/>
+              <a:t>55</a:t>
+            </a:fld>
+            <a:endParaRPr lang="en-US"/>
+          </a:p>
+        </p:txBody>
+      </p:sp>
+    </p:spTree>
+    <p:extLst>
+      <p:ext uri="{BB962C8B-B14F-4D97-AF65-F5344CB8AC3E}">
+        <p14:creationId xmlns:p14="http://schemas.microsoft.com/office/powerpoint/2010/main" val="1024086991"/>
+      </p:ext>
+    </p:extLst>
+  </p:cSld>
+  <p:clrMapOvr>
+    <a:masterClrMapping/>
+  </p:clrMapOvr>
+</p:notes>
+</file>
+
+<file path=ppt/notesSlides/notesSlide56.xml><?xml version="1.0" encoding="utf-8"?>
+<p:notes xmlns:a="http://schemas.openxmlformats.org/drawingml/2006/main" xmlns:r="http://schemas.openxmlformats.org/officeDocument/2006/relationships" xmlns:p="http://schemas.openxmlformats.org/presentationml/2006/main">
+  <p:cSld>
+    <p:spTree>
+      <p:nvGrpSpPr>
+        <p:cNvPr id="1" name=""/>
+        <p:cNvGrpSpPr/>
+        <p:nvPr/>
+      </p:nvGrpSpPr>
+      <p:grpSpPr>
+        <a:xfrm>
+          <a:off x="0" y="0"/>
+          <a:ext cx="0" cy="0"/>
+          <a:chOff x="0" y="0"/>
+          <a:chExt cx="0" cy="0"/>
+        </a:xfrm>
+      </p:grpSpPr>
+      <p:sp>
+        <p:nvSpPr>
+          <p:cNvPr id="2" name="Slide Image Placeholder 1"/>
+          <p:cNvSpPr>
+            <a:spLocks noGrp="1" noRot="1" noChangeAspect="1"/>
+          </p:cNvSpPr>
+          <p:nvPr>
+            <p:ph type="sldImg"/>
+          </p:nvPr>
+        </p:nvSpPr>
+        <p:spPr/>
+      </p:sp>
+      <p:sp>
+        <p:nvSpPr>
+          <p:cNvPr id="3" name="Notes Placeholder 2"/>
+          <p:cNvSpPr>
+            <a:spLocks noGrp="1"/>
+          </p:cNvSpPr>
+          <p:nvPr>
+            <p:ph type="body" idx="1"/>
+          </p:nvPr>
+        </p:nvSpPr>
+        <p:spPr/>
+        <p:txBody>
+          <a:bodyPr/>
+          <a:lstStyle/>
+          <a:p>
+            <a:r>
+              <a:rPr lang="en-US" dirty="0"/>
+              <a:t>These are the references and picture credits used to prepare this lesson.</a:t>
+            </a:r>
+            <a:endParaRPr lang="en-US" dirty="0"/>
+          </a:p>
+        </p:txBody>
+      </p:sp>
+      <p:sp>
+        <p:nvSpPr>
+          <p:cNvPr id="4" name="Slide Number Placeholder 3"/>
+          <p:cNvSpPr>
+            <a:spLocks noGrp="1"/>
+          </p:cNvSpPr>
+          <p:nvPr>
+            <p:ph type="sldNum" sz="quarter" idx="10"/>
+          </p:nvPr>
+        </p:nvSpPr>
+        <p:spPr/>
+        <p:txBody>
+          <a:bodyPr/>
+          <a:lstStyle/>
+          <a:p>
+            <a:fld id="{F7021451-1387-4CA6-816F-3879F97B5CBC}" type="slidenum">
+              <a:rPr lang="en-US"/>
+              <a:t>56</a:t>
             </a:fld>
             <a:endParaRPr lang="en-US"/>
           </a:p>
@@ -5042,7 +5309,7 @@
           <a:p>
             <a:r>
               <a:rPr lang="en-US" dirty="0"/>
-              <a:t>By the end of this lesson, you should be able to do three things. Number 1: recall local time, standard time and GMT. Number 2: calculate the local time of a place from its longitude. Number 3: compare the standard time of Cameroon with other countries.</a:t>
+              <a:t>By the end of this lesson, you should be able to do three things. Number 1: recall local time, standard time and GMT. Number 2: calculate the local time of a place from its longitude or from GMT. Number 3: compare the standard time of Cameroon with other countries.</a:t>
             </a:r>
             <a:endParaRPr lang="en-US" dirty="0"/>
           </a:p>
@@ -6510,7 +6777,7 @@
         <p:spPr>
           <a:xfrm>
             <a:off x="0" y="658368"/>
-            <a:ext cx="5120640" cy="5833872"/>
+            <a:ext cx="3840480" cy="5833872"/>
           </a:xfrm>
           <a:prstGeom prst="rect">
             <a:avLst/>
@@ -6525,8 +6792,8 @@
         </p:nvSpPr>
         <p:spPr>
           <a:xfrm>
-            <a:off x="5349240" y="1005840"/>
-            <a:ext cx="6522415" cy="731520"/>
+            <a:off x="4069080" y="1005840"/>
+            <a:ext cx="7802575" cy="731520"/>
           </a:xfrm>
           <a:prstGeom prst="rect">
             <a:avLst/>
@@ -6566,8 +6833,8 @@
         </p:nvSpPr>
         <p:spPr>
           <a:xfrm>
-            <a:off x="5349240" y="1783080"/>
-            <a:ext cx="6522415" cy="4663440"/>
+            <a:off x="4069080" y="1783080"/>
+            <a:ext cx="7802575" cy="4663440"/>
           </a:xfrm>
           <a:prstGeom prst="rect">
             <a:avLst/>
@@ -6594,7 +6861,7 @@
                 <a:ea typeface="Times New Roman" pitchFamily="34" charset="-122"/>
                 <a:cs typeface="Times New Roman" pitchFamily="34" charset="-120"/>
               </a:rPr>
-              <a:t>A football match starts at 20:00 in Paris. Moussa wants to watch it on television in Garoua, but he does not know at what time it will start in Cameroon.</a:t>
+              <a:t>A football match starts at 18:00 in London. Moussa wants to watch it on television in Garoua. He asks his friends: "At what time will the match start in Cameroon?" None of them can calculate it.</a:t>
             </a:r>
             <a:endParaRPr lang="en-US" sz="4000" dirty="0"/>
           </a:p>
@@ -7032,7 +7299,7 @@
                 <a:ea typeface="Times New Roman" pitchFamily="34" charset="-122"/>
                 <a:cs typeface="Times New Roman" pitchFamily="34" charset="-120"/>
               </a:rPr>
-              <a:t>Moussa does not know the time of the match in Cameroon.</a:t>
+              <a:t>Moussa and his friends do not know how to calculate the time of the match in Cameroon.</a:t>
             </a:r>
             <a:endParaRPr lang="en-US" sz="4000" dirty="0"/>
           </a:p>
@@ -7470,7 +7737,7 @@
                 <a:ea typeface="Times New Roman" pitchFamily="34" charset="-122"/>
                 <a:cs typeface="Times New Roman" pitchFamily="34" charset="-120"/>
               </a:rPr>
-              <a:t>The time difference between Paris and Cameroon.</a:t>
+              <a:t>The time difference between London and Cameroon.</a:t>
             </a:r>
             <a:endParaRPr lang="en-US" sz="4000" dirty="0"/>
           </a:p>
@@ -7908,7 +8175,7 @@
                 <a:ea typeface="Times New Roman" pitchFamily="34" charset="-122"/>
                 <a:cs typeface="Times New Roman" pitchFamily="34" charset="-120"/>
               </a:rPr>
-              <a:t>By using the time zones or the longitudes.</a:t>
+              <a:t>By using the longitudes or the time zones.</a:t>
             </a:r>
             <a:endParaRPr lang="en-US" sz="4000" dirty="0"/>
           </a:p>
@@ -9593,7 +9860,7 @@
                 <a:ea typeface="Times New Roman" pitchFamily="34" charset="-122"/>
                 <a:cs typeface="Times New Roman" pitchFamily="34" charset="-120"/>
               </a:rPr>
-              <a:t>360 ÷ 24 = 15° per hour, so 1° = 4 minutes.</a:t>
+              <a:t>360 ÷ 24 = 15° per hour, so 1° takes 4 minutes.</a:t>
             </a:r>
             <a:endParaRPr lang="en-US" sz="4000" dirty="0"/>
           </a:p>
@@ -10245,7 +10512,7 @@
                 <a:ea typeface="Times New Roman" pitchFamily="34" charset="-122"/>
                 <a:cs typeface="Times New Roman" pitchFamily="34" charset="-120"/>
               </a:rPr>
-              <a:t>30 × 4 min = 120 min = 2 hours; the place is east, so 12:00 + 2 h = 14:00.</a:t>
+              <a:t>30 × 4 min = 120 min = 2 hours; the place is to the east, so 12:00 + 2 h = 14:00.</a:t>
             </a:r>
             <a:endParaRPr lang="en-US" sz="4000" dirty="0"/>
           </a:p>
@@ -10897,7 +11164,7 @@
                 <a:ea typeface="Times New Roman" pitchFamily="34" charset="-122"/>
                 <a:cs typeface="Times New Roman" pitchFamily="34" charset="-120"/>
               </a:rPr>
-              <a:t>45 × 4 = 180 min = 3 hours; the place is west, so 10:00 − 3 h = 07:00.</a:t>
+              <a:t>45 × 4 = 180 min = 3 hours; the place is to the west, so 10:00 − 3 h = 07:00.</a:t>
             </a:r>
             <a:endParaRPr lang="en-US" sz="4000" dirty="0"/>
           </a:p>
@@ -12151,7 +12418,7 @@
                           <a:ea typeface="Calibri" pitchFamily="34" charset="-122"/>
                           <a:cs typeface="Calibri" pitchFamily="34" charset="-120"/>
                         </a:rPr>
-                        <a:t>Revision of local and standard time; calculation of local time; calculation of the local time of a place from GMT; basis of time zones; Cameroon's standard time compared with other areas.</a:t>
+                        <a:t>Theoretical basis: revision of local and standard time. Practical exercise: calculation of local time; calculation of the local time of a place from GMT; basis of carving out time zones. Contextualisation: establish Cameroon's standard time compared with other areas.</a:t>
                       </a:r>
                       <a:endParaRPr lang="en-US" sz="1700" dirty="0">
                         <a:latin typeface="Calibri" charset="0"/>
@@ -12558,7 +12825,7 @@
                 <a:ea typeface="Times New Roman" pitchFamily="34" charset="-122"/>
                 <a:cs typeface="Times New Roman" pitchFamily="34" charset="-120"/>
               </a:rPr>
-              <a:t>To avoid a different time in every town; each zone of about 15° uses the same standard time.</a:t>
+              <a:t>To avoid a different time in every town: each zone of about 15° uses the same standard time.</a:t>
             </a:r>
             <a:endParaRPr lang="en-US" sz="4000" dirty="0"/>
           </a:p>
@@ -12670,7 +12937,7 @@
                 <a:ea typeface="Calibri" pitchFamily="34" charset="-122"/>
                 <a:cs typeface="Calibri" pitchFamily="34" charset="-120"/>
               </a:rPr>
-              <a:t>3. CAMEROON'S STANDARD TIME</a:t>
+              <a:t>4. CAMEROON'S STANDARD TIME</a:t>
             </a:r>
             <a:endParaRPr lang="en-US" sz="1400" dirty="0"/>
           </a:p>
@@ -12884,7 +13151,7 @@
                 <a:ea typeface="Calibri" pitchFamily="34" charset="-122"/>
                 <a:cs typeface="Calibri" pitchFamily="34" charset="-120"/>
               </a:rPr>
-              <a:t>3. CAMEROON'S STANDARD TIME</a:t>
+              <a:t>4. CAMEROON'S STANDARD TIME</a:t>
             </a:r>
             <a:endParaRPr lang="en-US" sz="1400" dirty="0"/>
           </a:p>
@@ -12991,7 +13258,7 @@
                 <a:ea typeface="Times New Roman" pitchFamily="34" charset="-122"/>
                 <a:cs typeface="Times New Roman" pitchFamily="34" charset="-120"/>
               </a:rPr>
-              <a:t>Cameroon uses GMT + 1. When it is 12:00 in Garoua, what time is it in London (GMT) and in Dubai (GMT + 4)?</a:t>
+              <a:t>When it is 12:00 in Garoua (GMT + 1), what time is it in London (GMT)?</a:t>
             </a:r>
             <a:endParaRPr lang="en-US" sz="4000" dirty="0"/>
           </a:p>
@@ -13103,7 +13370,7 @@
                 <a:ea typeface="Calibri" pitchFamily="34" charset="-122"/>
                 <a:cs typeface="Calibri" pitchFamily="34" charset="-120"/>
               </a:rPr>
-              <a:t>3. CAMEROON'S STANDARD TIME</a:t>
+              <a:t>4. CAMEROON'S STANDARD TIME</a:t>
             </a:r>
             <a:endParaRPr lang="en-US" sz="1400" dirty="0"/>
           </a:p>
@@ -13210,7 +13477,7 @@
                 <a:ea typeface="Times New Roman" pitchFamily="34" charset="-122"/>
                 <a:cs typeface="Times New Roman" pitchFamily="34" charset="-120"/>
               </a:rPr>
-              <a:t>London: 11:00. Dubai: 15:00.</a:t>
+              <a:t>11:00.</a:t>
             </a:r>
             <a:endParaRPr lang="en-US" sz="4000" dirty="0"/>
           </a:p>
@@ -14116,9 +14383,129 @@
           </a:p>
         </p:txBody>
       </p:sp>
+      <p:sp>
+        <p:nvSpPr>
+          <p:cNvPr id="3" name="Text 1"/>
+          <p:cNvSpPr/>
+          <p:nvPr/>
+        </p:nvSpPr>
+        <p:spPr>
+          <a:xfrm>
+            <a:off x="365760" y="1005840"/>
+            <a:ext cx="11460175" cy="731520"/>
+          </a:xfrm>
+          <a:prstGeom prst="rect">
+            <a:avLst/>
+          </a:prstGeom>
+          <a:noFill/>
+          <a:ln/>
+        </p:spPr>
+        <p:txBody>
+          <a:bodyPr wrap="square" lIns="0" tIns="0" rIns="0" bIns="0" rtlCol="0" anchor="ctr">
+            <a:normAutofit/>
+          </a:bodyPr>
+          <a:lstStyle/>
+          <a:p>
+            <a:pPr algn="ctr" indent="0" marL="0">
+              <a:buNone/>
+            </a:pPr>
+            <a:r>
+              <a:rPr lang="en-US" sz="3600" b="1" dirty="0">
+                <a:solidFill>
+                  <a:srgbClr val="990011"/>
+                </a:solidFill>
+                <a:latin typeface="Times New Roman" pitchFamily="34" charset="0"/>
+                <a:ea typeface="Times New Roman" pitchFamily="34" charset="-122"/>
+                <a:cs typeface="Times New Roman" pitchFamily="34" charset="-120"/>
+              </a:rPr>
+              <a:t>1. Rules for Calculating Local Time</a:t>
+            </a:r>
+            <a:endParaRPr lang="en-US" sz="3600" dirty="0"/>
+          </a:p>
+        </p:txBody>
+      </p:sp>
+      <p:sp>
+        <p:nvSpPr>
+          <p:cNvPr id="4" name="Text 2"/>
+          <p:cNvSpPr/>
+          <p:nvPr/>
+        </p:nvSpPr>
+        <p:spPr>
+          <a:xfrm>
+            <a:off x="365760" y="1783080"/>
+            <a:ext cx="4846320" cy="4617720"/>
+          </a:xfrm>
+          <a:prstGeom prst="rect">
+            <a:avLst/>
+          </a:prstGeom>
+          <a:noFill/>
+          <a:ln/>
+        </p:spPr>
+        <p:txBody>
+          <a:bodyPr wrap="square" lIns="0" tIns="0" rIns="0" bIns="0" rtlCol="0" anchor="t"/>
+          <a:lstStyle/>
+          <a:p>
+            <a:pPr algn="l" indent="0" marL="0">
+              <a:spcAft>
+                <a:spcPts val="800"/>
+              </a:spcAft>
+              <a:buNone/>
+            </a:pPr>
+            <a:r>
+              <a:rPr lang="en-US" sz="3600" i="1" dirty="0">
+                <a:solidFill>
+                  <a:srgbClr val="111111"/>
+                </a:solidFill>
+                <a:latin typeface="Times New Roman" pitchFamily="34" charset="0"/>
+                <a:ea typeface="Times New Roman" pitchFamily="34" charset="-122"/>
+                <a:cs typeface="Times New Roman" pitchFamily="34" charset="-120"/>
+              </a:rPr>
+              <a:t>We calculate local time with the following rules:</a:t>
+            </a:r>
+            <a:endParaRPr lang="en-US" sz="3600" dirty="0"/>
+          </a:p>
+          <a:p>
+            <a:pPr algn="l" indent="0" marL="0">
+              <a:spcAft>
+                <a:spcPts val="800"/>
+              </a:spcAft>
+              <a:buNone/>
+            </a:pPr>
+            <a:r>
+              <a:rPr lang="en-US" sz="3600" b="1" dirty="0">
+                <a:solidFill>
+                  <a:srgbClr val="111111"/>
+                </a:solidFill>
+                <a:latin typeface="Times New Roman" pitchFamily="34" charset="0"/>
+                <a:ea typeface="Times New Roman" pitchFamily="34" charset="-122"/>
+                <a:cs typeface="Times New Roman" pitchFamily="34" charset="-120"/>
+              </a:rPr>
+              <a:t>Rule 1: </a:t>
+            </a:r>
+            <a:pPr algn="l" indent="0" marL="0">
+              <a:spcAft>
+                <a:spcPts val="800"/>
+              </a:spcAft>
+              <a:buNone/>
+            </a:pPr>
+            <a:r>
+              <a:rPr lang="en-US" sz="3600" dirty="0">
+                <a:solidFill>
+                  <a:srgbClr val="111111"/>
+                </a:solidFill>
+                <a:latin typeface="Times New Roman" pitchFamily="34" charset="0"/>
+                <a:ea typeface="Times New Roman" pitchFamily="34" charset="-122"/>
+                <a:cs typeface="Times New Roman" pitchFamily="34" charset="-120"/>
+              </a:rPr>
+              <a:t>The Earth turns 15° in one hour, so 1° of longitude equals 4 minutes.</a:t>
+            </a:r>
+            <a:endParaRPr lang="en-US" sz="3600" dirty="0"/>
+          </a:p>
+        </p:txBody>
+      </p:sp>
       <p:pic>
         <p:nvPicPr>
-          <p:cNvPr id="3" name="Image 0" descr="/home/claude/f4/img/minesec_sheet.png">    </p:cNvPr>
+          <p:cNvPr id="5" name="Image 0" descr="/home/claude/f4/img/v2/time_line_big.png">    </p:cNvPr>
           <p:cNvPicPr>
             <a:picLocks noChangeAspect="1"/>
           </p:cNvPicPr>
@@ -14132,8 +14519,8 @@
         </p:blipFill>
         <p:spPr>
           <a:xfrm>
-            <a:off x="0" y="658368"/>
-            <a:ext cx="2468880" cy="5833872"/>
+            <a:off x="5349240" y="2617506"/>
+            <a:ext cx="6659575" cy="2601397"/>
           </a:xfrm>
           <a:prstGeom prst="rect">
             <a:avLst/>
@@ -14142,14 +14529,14 @@
       </p:pic>
       <p:sp>
         <p:nvSpPr>
-          <p:cNvPr id="4" name="Text 1"/>
+          <p:cNvPr id="6" name="Text 3"/>
           <p:cNvSpPr/>
           <p:nvPr/>
         </p:nvSpPr>
         <p:spPr>
           <a:xfrm>
-            <a:off x="2697480" y="1005840"/>
-            <a:ext cx="9174175" cy="731520"/>
+            <a:off x="5349240" y="6089904"/>
+            <a:ext cx="6659575" cy="347472"/>
           </a:xfrm>
           <a:prstGeom prst="rect">
             <a:avLst/>
@@ -14158,142 +14545,24 @@
           <a:ln/>
         </p:spPr>
         <p:txBody>
-          <a:bodyPr wrap="square" lIns="0" tIns="0" rIns="0" bIns="0" rtlCol="0" anchor="ctr">
-            <a:normAutofit/>
-          </a:bodyPr>
+          <a:bodyPr wrap="square" lIns="0" tIns="0" rIns="0" bIns="0" rtlCol="0" anchor="ctr"/>
           <a:lstStyle/>
           <a:p>
             <a:pPr algn="ctr" indent="0" marL="0">
               <a:buNone/>
             </a:pPr>
             <a:r>
-              <a:rPr lang="en-US" sz="3600" b="1" dirty="0">
-                <a:solidFill>
-                  <a:srgbClr val="990011"/>
+              <a:rPr lang="en-US" sz="1600" i="1" dirty="0">
+                <a:solidFill>
+                  <a:srgbClr val="555555"/>
                 </a:solidFill>
                 <a:latin typeface="Times New Roman" pitchFamily="34" charset="0"/>
                 <a:ea typeface="Times New Roman" pitchFamily="34" charset="-122"/>
                 <a:cs typeface="Times New Roman" pitchFamily="34" charset="-120"/>
               </a:rPr>
-              <a:t>1. Rules for Calculating Time</a:t>
-            </a:r>
-            <a:endParaRPr lang="en-US" sz="3600" dirty="0"/>
-          </a:p>
-        </p:txBody>
-      </p:sp>
-      <p:sp>
-        <p:nvSpPr>
-          <p:cNvPr id="5" name="Text 2"/>
-          <p:cNvSpPr/>
-          <p:nvPr/>
-        </p:nvSpPr>
-        <p:spPr>
-          <a:xfrm>
-            <a:off x="2697480" y="1783080"/>
-            <a:ext cx="9174175" cy="4663440"/>
-          </a:xfrm>
-          <a:prstGeom prst="rect">
-            <a:avLst/>
-          </a:prstGeom>
-          <a:noFill/>
-          <a:ln/>
-        </p:spPr>
-        <p:txBody>
-          <a:bodyPr wrap="square" lIns="0" tIns="0" rIns="0" bIns="0" rtlCol="0" anchor="t"/>
-          <a:lstStyle/>
-          <a:p>
-            <a:pPr algn="l" indent="0" marL="0">
-              <a:spcAft>
-                <a:spcPts val="800"/>
-              </a:spcAft>
-              <a:buNone/>
-            </a:pPr>
-            <a:r>
-              <a:rPr lang="en-US" sz="4000" i="1" dirty="0">
-                <a:solidFill>
-                  <a:srgbClr val="111111"/>
-                </a:solidFill>
-                <a:latin typeface="Times New Roman" pitchFamily="34" charset="0"/>
-                <a:ea typeface="Times New Roman" pitchFamily="34" charset="-122"/>
-                <a:cs typeface="Times New Roman" pitchFamily="34" charset="-120"/>
-              </a:rPr>
-              <a:t>We calculate time with the following rules:</a:t>
-            </a:r>
-            <a:endParaRPr lang="en-US" sz="4000" dirty="0"/>
-          </a:p>
-          <a:p>
-            <a:pPr algn="l" indent="0" marL="0">
-              <a:spcAft>
-                <a:spcPts val="800"/>
-              </a:spcAft>
-              <a:buNone/>
-            </a:pPr>
-            <a:r>
-              <a:rPr lang="en-US" sz="4000" b="1" dirty="0">
-                <a:solidFill>
-                  <a:srgbClr val="111111"/>
-                </a:solidFill>
-                <a:latin typeface="Times New Roman" pitchFamily="34" charset="0"/>
-                <a:ea typeface="Times New Roman" pitchFamily="34" charset="-122"/>
-                <a:cs typeface="Times New Roman" pitchFamily="34" charset="-120"/>
-              </a:rPr>
-              <a:t>Rule 1: </a:t>
-            </a:r>
-            <a:pPr algn="l" indent="0" marL="0">
-              <a:spcAft>
-                <a:spcPts val="800"/>
-              </a:spcAft>
-              <a:buNone/>
-            </a:pPr>
-            <a:r>
-              <a:rPr lang="en-US" sz="4000" dirty="0">
-                <a:solidFill>
-                  <a:srgbClr val="111111"/>
-                </a:solidFill>
-                <a:latin typeface="Times New Roman" pitchFamily="34" charset="0"/>
-                <a:ea typeface="Times New Roman" pitchFamily="34" charset="-122"/>
-                <a:cs typeface="Times New Roman" pitchFamily="34" charset="-120"/>
-              </a:rPr>
-              <a:t>The Earth turns 15° in one hour, so 1° of longitude equals 4 minutes.</a:t>
-            </a:r>
-            <a:endParaRPr lang="en-US" sz="4000" dirty="0"/>
-          </a:p>
-          <a:p>
-            <a:pPr algn="l" indent="0" marL="0">
-              <a:spcAft>
-                <a:spcPts val="800"/>
-              </a:spcAft>
-              <a:buNone/>
-            </a:pPr>
-            <a:r>
-              <a:rPr lang="en-US" sz="4000" b="1" dirty="0">
-                <a:solidFill>
-                  <a:srgbClr val="111111"/>
-                </a:solidFill>
-                <a:latin typeface="Times New Roman" pitchFamily="34" charset="0"/>
-                <a:ea typeface="Times New Roman" pitchFamily="34" charset="-122"/>
-                <a:cs typeface="Times New Roman" pitchFamily="34" charset="-120"/>
-              </a:rPr>
-              <a:t>Rule 2: </a:t>
-            </a:r>
-            <a:pPr algn="l" indent="0" marL="0">
-              <a:spcAft>
-                <a:spcPts val="800"/>
-              </a:spcAft>
-              <a:buNone/>
-            </a:pPr>
-            <a:r>
-              <a:rPr lang="en-US" sz="4000" dirty="0">
-                <a:solidFill>
-                  <a:srgbClr val="111111"/>
-                </a:solidFill>
-                <a:latin typeface="Times New Roman" pitchFamily="34" charset="0"/>
-                <a:ea typeface="Times New Roman" pitchFamily="34" charset="-122"/>
-                <a:cs typeface="Times New Roman" pitchFamily="34" charset="-120"/>
-              </a:rPr>
-              <a:t>We add time for places to the east and remove time for places to the west.</a:t>
-            </a:r>
-            <a:endParaRPr lang="en-US" sz="4000" dirty="0"/>
+              <a:t>Illustration: time and longitude</a:t>
+            </a:r>
+            <a:endParaRPr lang="en-US" sz="1600" dirty="0"/>
           </a:p>
         </p:txBody>
       </p:sp>
@@ -14426,7 +14695,7 @@
         <p:spPr>
           <a:xfrm>
             <a:off x="0" y="658368"/>
-            <a:ext cx="5120640" cy="5833872"/>
+            <a:ext cx="3840480" cy="5833872"/>
           </a:xfrm>
           <a:prstGeom prst="rect">
             <a:avLst/>
@@ -14441,8 +14710,8 @@
         </p:nvSpPr>
         <p:spPr>
           <a:xfrm>
-            <a:off x="5349240" y="1005840"/>
-            <a:ext cx="6522415" cy="731520"/>
+            <a:off x="4069080" y="1005840"/>
+            <a:ext cx="7802575" cy="731520"/>
           </a:xfrm>
           <a:prstGeom prst="rect">
             <a:avLst/>
@@ -14468,7 +14737,7 @@
                 <a:ea typeface="Times New Roman" pitchFamily="34" charset="-122"/>
                 <a:cs typeface="Times New Roman" pitchFamily="34" charset="-120"/>
               </a:rPr>
-              <a:t>1. Rules for Calculating Time (continued)</a:t>
+              <a:t>1. Rules for Calculating Local Time</a:t>
             </a:r>
             <a:endParaRPr lang="en-US" sz="3600" dirty="0"/>
           </a:p>
@@ -14482,8 +14751,8 @@
         </p:nvSpPr>
         <p:spPr>
           <a:xfrm>
-            <a:off x="5349240" y="1783080"/>
-            <a:ext cx="6522415" cy="4663440"/>
+            <a:off x="4069080" y="1783080"/>
+            <a:ext cx="7802575" cy="4663440"/>
           </a:xfrm>
           <a:prstGeom prst="rect">
             <a:avLst/>
@@ -14494,6 +14763,43 @@
         <p:txBody>
           <a:bodyPr wrap="square" lIns="0" tIns="0" rIns="0" bIns="0" rtlCol="0" anchor="t"/>
           <a:lstStyle/>
+          <a:p>
+            <a:pPr algn="l" indent="0" marL="0">
+              <a:spcAft>
+                <a:spcPts val="800"/>
+              </a:spcAft>
+              <a:buNone/>
+            </a:pPr>
+            <a:r>
+              <a:rPr lang="en-US" sz="4000" b="1" dirty="0">
+                <a:solidFill>
+                  <a:srgbClr val="111111"/>
+                </a:solidFill>
+                <a:latin typeface="Times New Roman" pitchFamily="34" charset="0"/>
+                <a:ea typeface="Times New Roman" pitchFamily="34" charset="-122"/>
+                <a:cs typeface="Times New Roman" pitchFamily="34" charset="-120"/>
+              </a:rPr>
+              <a:t>Rule 2: </a:t>
+            </a:r>
+            <a:pPr algn="l" indent="0" marL="0">
+              <a:spcAft>
+                <a:spcPts val="800"/>
+              </a:spcAft>
+              <a:buNone/>
+            </a:pPr>
+            <a:r>
+              <a:rPr lang="en-US" sz="4000" dirty="0">
+                <a:solidFill>
+                  <a:srgbClr val="111111"/>
+                </a:solidFill>
+                <a:latin typeface="Times New Roman" pitchFamily="34" charset="0"/>
+                <a:ea typeface="Times New Roman" pitchFamily="34" charset="-122"/>
+                <a:cs typeface="Times New Roman" pitchFamily="34" charset="-120"/>
+              </a:rPr>
+              <a:t>We add time for places to the east and remove time for places to the west.</a:t>
+            </a:r>
+            <a:endParaRPr lang="en-US" sz="4000" dirty="0"/>
+          </a:p>
           <a:p>
             <a:pPr algn="l" indent="0" marL="0">
               <a:spcAft>
@@ -14653,8 +14959,8 @@
         </p:nvSpPr>
         <p:spPr>
           <a:xfrm>
-            <a:off x="457200" y="1005840"/>
-            <a:ext cx="11277295" cy="731520"/>
+            <a:off x="365760" y="1005840"/>
+            <a:ext cx="11460175" cy="731520"/>
           </a:xfrm>
           <a:prstGeom prst="rect">
             <a:avLst/>
@@ -14663,7 +14969,9 @@
           <a:ln/>
         </p:spPr>
         <p:txBody>
-          <a:bodyPr wrap="square" lIns="0" tIns="0" rIns="0" bIns="0" rtlCol="0" anchor="ctr"/>
+          <a:bodyPr wrap="square" lIns="0" tIns="0" rIns="0" bIns="0" rtlCol="0" anchor="ctr">
+            <a:normAutofit/>
+          </a:bodyPr>
           <a:lstStyle/>
           <a:p>
             <a:pPr algn="ctr" indent="0" marL="0">
@@ -14678,15 +14986,94 @@
                 <a:ea typeface="Times New Roman" pitchFamily="34" charset="-122"/>
                 <a:cs typeface="Times New Roman" pitchFamily="34" charset="-120"/>
               </a:rPr>
-              <a:t>1. Rules for Calculating Time</a:t>
+              <a:t>2. Calculating Local Time from GMT</a:t>
             </a:r>
             <a:endParaRPr lang="en-US" sz="3600" dirty="0"/>
+          </a:p>
+        </p:txBody>
+      </p:sp>
+      <p:sp>
+        <p:nvSpPr>
+          <p:cNvPr id="4" name="Text 2"/>
+          <p:cNvSpPr/>
+          <p:nvPr/>
+        </p:nvSpPr>
+        <p:spPr>
+          <a:xfrm>
+            <a:off x="365760" y="1783080"/>
+            <a:ext cx="4846320" cy="4617720"/>
+          </a:xfrm>
+          <a:prstGeom prst="rect">
+            <a:avLst/>
+          </a:prstGeom>
+          <a:noFill/>
+          <a:ln/>
+        </p:spPr>
+        <p:txBody>
+          <a:bodyPr wrap="square" lIns="0" tIns="0" rIns="0" bIns="0" rtlCol="0" anchor="t"/>
+          <a:lstStyle/>
+          <a:p>
+            <a:pPr algn="l" indent="0" marL="0">
+              <a:spcAft>
+                <a:spcPts val="800"/>
+              </a:spcAft>
+              <a:buNone/>
+            </a:pPr>
+            <a:r>
+              <a:rPr lang="en-US" sz="3400" i="1" dirty="0">
+                <a:solidFill>
+                  <a:srgbClr val="111111"/>
+                </a:solidFill>
+                <a:latin typeface="Times New Roman" pitchFamily="34" charset="0"/>
+                <a:ea typeface="Times New Roman" pitchFamily="34" charset="-122"/>
+                <a:cs typeface="Times New Roman" pitchFamily="34" charset="-120"/>
+              </a:rPr>
+              <a:t>We calculate local time from GMT as in the following examples:</a:t>
+            </a:r>
+            <a:endParaRPr lang="en-US" sz="3400" dirty="0"/>
+          </a:p>
+          <a:p>
+            <a:pPr algn="l" indent="0" marL="0">
+              <a:spcAft>
+                <a:spcPts val="800"/>
+              </a:spcAft>
+              <a:buNone/>
+            </a:pPr>
+            <a:r>
+              <a:rPr lang="en-US" sz="3400" b="1" dirty="0">
+                <a:solidFill>
+                  <a:srgbClr val="111111"/>
+                </a:solidFill>
+                <a:latin typeface="Times New Roman" pitchFamily="34" charset="0"/>
+                <a:ea typeface="Times New Roman" pitchFamily="34" charset="-122"/>
+                <a:cs typeface="Times New Roman" pitchFamily="34" charset="-120"/>
+              </a:rPr>
+              <a:t>Example to the east: </a:t>
+            </a:r>
+            <a:pPr algn="l" indent="0" marL="0">
+              <a:spcAft>
+                <a:spcPts val="800"/>
+              </a:spcAft>
+              <a:buNone/>
+            </a:pPr>
+            <a:r>
+              <a:rPr lang="en-US" sz="3400" dirty="0">
+                <a:solidFill>
+                  <a:srgbClr val="111111"/>
+                </a:solidFill>
+                <a:latin typeface="Times New Roman" pitchFamily="34" charset="0"/>
+                <a:ea typeface="Times New Roman" pitchFamily="34" charset="-122"/>
+                <a:cs typeface="Times New Roman" pitchFamily="34" charset="-120"/>
+              </a:rPr>
+              <a:t>It is 12:00 GMT. At 30° E, the difference is 30 × 4 = 120 min = 2 h, so the local time is 14:00.</a:t>
+            </a:r>
+            <a:endParaRPr lang="en-US" sz="3400" dirty="0"/>
           </a:p>
         </p:txBody>
       </p:sp>
       <p:pic>
         <p:nvPicPr>
-          <p:cNvPr id="4" name="Image 0" descr="/home/claude/f4/img/v2/time_calc_big.png">    </p:cNvPr>
+          <p:cNvPr id="5" name="Image 0" descr="/home/claude/f4/img/v2/time_calc_big.png">    </p:cNvPr>
           <p:cNvPicPr>
             <a:picLocks noChangeAspect="1"/>
           </p:cNvPicPr>
@@ -14700,8 +15087,8 @@
         </p:blipFill>
         <p:spPr>
           <a:xfrm>
-            <a:off x="629930" y="1783080"/>
-            <a:ext cx="10931835" cy="4270248"/>
+            <a:off x="5349240" y="2617506"/>
+            <a:ext cx="6659575" cy="2601397"/>
           </a:xfrm>
           <a:prstGeom prst="rect">
             <a:avLst/>
@@ -14710,14 +15097,14 @@
       </p:pic>
       <p:sp>
         <p:nvSpPr>
-          <p:cNvPr id="5" name="Text 2"/>
+          <p:cNvPr id="6" name="Text 3"/>
           <p:cNvSpPr/>
           <p:nvPr/>
         </p:nvSpPr>
         <p:spPr>
           <a:xfrm>
-            <a:off x="457200" y="6089904"/>
-            <a:ext cx="11277295" cy="347472"/>
+            <a:off x="5349240" y="6089904"/>
+            <a:ext cx="6659575" cy="347472"/>
           </a:xfrm>
           <a:prstGeom prst="rect">
             <a:avLst/>
@@ -14733,7 +15120,7 @@
               <a:buNone/>
             </a:pPr>
             <a:r>
-              <a:rPr lang="en-US" sz="1800" i="1" dirty="0">
+              <a:rPr lang="en-US" sz="1600" i="1" dirty="0">
                 <a:solidFill>
                   <a:srgbClr val="555555"/>
                 </a:solidFill>
@@ -14743,7 +15130,7 @@
               </a:rPr>
               <a:t>Illustration: calculating local time</a:t>
             </a:r>
-            <a:endParaRPr lang="en-US" sz="1800" dirty="0"/>
+            <a:endParaRPr lang="en-US" sz="1600" dirty="0"/>
           </a:p>
         </p:txBody>
       </p:sp>
@@ -15115,7 +15502,7 @@
         <p:spPr>
           <a:xfrm>
             <a:off x="0" y="658368"/>
-            <a:ext cx="3840480" cy="5833872"/>
+            <a:ext cx="5120640" cy="5833872"/>
           </a:xfrm>
           <a:prstGeom prst="rect">
             <a:avLst/>
@@ -15130,8 +15517,8 @@
         </p:nvSpPr>
         <p:spPr>
           <a:xfrm>
-            <a:off x="4069080" y="1005840"/>
-            <a:ext cx="7802575" cy="731520"/>
+            <a:off x="5349240" y="1005840"/>
+            <a:ext cx="6522415" cy="731520"/>
           </a:xfrm>
           <a:prstGeom prst="rect">
             <a:avLst/>
@@ -15157,7 +15544,7 @@
                 <a:ea typeface="Times New Roman" pitchFamily="34" charset="-122"/>
                 <a:cs typeface="Times New Roman" pitchFamily="34" charset="-120"/>
               </a:rPr>
-              <a:t>2. Time Zones and Cameroon's Standard Time</a:t>
+              <a:t>2. Calculating Local Time from GMT</a:t>
             </a:r>
             <a:endParaRPr lang="en-US" sz="3600" dirty="0"/>
           </a:p>
@@ -15171,8 +15558,8 @@
         </p:nvSpPr>
         <p:spPr>
           <a:xfrm>
-            <a:off x="4069080" y="1783080"/>
-            <a:ext cx="7802575" cy="4663440"/>
+            <a:off x="5349240" y="1783080"/>
+            <a:ext cx="6522415" cy="4663440"/>
           </a:xfrm>
           <a:prstGeom prst="rect">
             <a:avLst/>
@@ -15191,7 +15578,7 @@
               <a:buNone/>
             </a:pPr>
             <a:r>
-              <a:rPr lang="en-US" sz="4000" i="1" dirty="0">
+              <a:rPr lang="en-US" sz="4000" b="1" dirty="0">
                 <a:solidFill>
                   <a:srgbClr val="111111"/>
                 </a:solidFill>
@@ -15199,11 +15586,8 @@
                 <a:ea typeface="Times New Roman" pitchFamily="34" charset="-122"/>
                 <a:cs typeface="Times New Roman" pitchFamily="34" charset="-120"/>
               </a:rPr>
-              <a:t>Time zones are organised as follows:</a:t>
-            </a:r>
-            <a:endParaRPr lang="en-US" sz="4000" dirty="0"/>
-          </a:p>
-          <a:p>
+              <a:t>Example to the west: </a:t>
+            </a:r>
             <a:pPr algn="l" indent="0" marL="0">
               <a:spcAft>
                 <a:spcPts val="800"/>
@@ -15211,7 +15595,7 @@
               <a:buNone/>
             </a:pPr>
             <a:r>
-              <a:rPr lang="en-US" sz="4000" b="1" dirty="0">
+              <a:rPr lang="en-US" sz="4000" dirty="0">
                 <a:solidFill>
                   <a:srgbClr val="111111"/>
                 </a:solidFill>
@@ -15219,61 +15603,7 @@
                 <a:ea typeface="Times New Roman" pitchFamily="34" charset="-122"/>
                 <a:cs typeface="Times New Roman" pitchFamily="34" charset="-120"/>
               </a:rPr>
-              <a:t>Basis of time zones: </a:t>
-            </a:r>
-            <a:pPr algn="l" indent="0" marL="0">
-              <a:spcAft>
-                <a:spcPts val="800"/>
-              </a:spcAft>
-              <a:buNone/>
-            </a:pPr>
-            <a:r>
-              <a:rPr lang="en-US" sz="4000" dirty="0">
-                <a:solidFill>
-                  <a:srgbClr val="111111"/>
-                </a:solidFill>
-                <a:latin typeface="Times New Roman" pitchFamily="34" charset="0"/>
-                <a:ea typeface="Times New Roman" pitchFamily="34" charset="-122"/>
-                <a:cs typeface="Times New Roman" pitchFamily="34" charset="-120"/>
-              </a:rPr>
-              <a:t>The world is divided into 24 time zones of about 15° each.</a:t>
-            </a:r>
-            <a:endParaRPr lang="en-US" sz="4000" dirty="0"/>
-          </a:p>
-          <a:p>
-            <a:pPr algn="l" indent="0" marL="0">
-              <a:spcAft>
-                <a:spcPts val="800"/>
-              </a:spcAft>
-              <a:buNone/>
-            </a:pPr>
-            <a:r>
-              <a:rPr lang="en-US" sz="4000" b="1" dirty="0">
-                <a:solidFill>
-                  <a:srgbClr val="111111"/>
-                </a:solidFill>
-                <a:latin typeface="Times New Roman" pitchFamily="34" charset="0"/>
-                <a:ea typeface="Times New Roman" pitchFamily="34" charset="-122"/>
-                <a:cs typeface="Times New Roman" pitchFamily="34" charset="-120"/>
-              </a:rPr>
-              <a:t>Cameroon: </a:t>
-            </a:r>
-            <a:pPr algn="l" indent="0" marL="0">
-              <a:spcAft>
-                <a:spcPts val="800"/>
-              </a:spcAft>
-              <a:buNone/>
-            </a:pPr>
-            <a:r>
-              <a:rPr lang="en-US" sz="4000" dirty="0">
-                <a:solidFill>
-                  <a:srgbClr val="111111"/>
-                </a:solidFill>
-                <a:latin typeface="Times New Roman" pitchFamily="34" charset="0"/>
-                <a:ea typeface="Times New Roman" pitchFamily="34" charset="-122"/>
-                <a:cs typeface="Times New Roman" pitchFamily="34" charset="-120"/>
-              </a:rPr>
-              <a:t>Cameroon uses West Africa Time, which is GMT + 1.</a:t>
+              <a:t>It is 10:00 GMT. At 45° W, the difference is 45 × 4 = 180 min = 3 h, so the local time is 07:00.</a:t>
             </a:r>
             <a:endParaRPr lang="en-US" sz="4000" dirty="0"/>
           </a:p>
@@ -15391,9 +15721,129 @@
           </a:p>
         </p:txBody>
       </p:sp>
+      <p:sp>
+        <p:nvSpPr>
+          <p:cNvPr id="3" name="Text 1"/>
+          <p:cNvSpPr/>
+          <p:nvPr/>
+        </p:nvSpPr>
+        <p:spPr>
+          <a:xfrm>
+            <a:off x="365760" y="1005840"/>
+            <a:ext cx="11460175" cy="731520"/>
+          </a:xfrm>
+          <a:prstGeom prst="rect">
+            <a:avLst/>
+          </a:prstGeom>
+          <a:noFill/>
+          <a:ln/>
+        </p:spPr>
+        <p:txBody>
+          <a:bodyPr wrap="square" lIns="0" tIns="0" rIns="0" bIns="0" rtlCol="0" anchor="ctr">
+            <a:normAutofit/>
+          </a:bodyPr>
+          <a:lstStyle/>
+          <a:p>
+            <a:pPr algn="ctr" indent="0" marL="0">
+              <a:buNone/>
+            </a:pPr>
+            <a:r>
+              <a:rPr lang="en-US" sz="3600" b="1" dirty="0">
+                <a:solidFill>
+                  <a:srgbClr val="990011"/>
+                </a:solidFill>
+                <a:latin typeface="Times New Roman" pitchFamily="34" charset="0"/>
+                <a:ea typeface="Times New Roman" pitchFamily="34" charset="-122"/>
+                <a:cs typeface="Times New Roman" pitchFamily="34" charset="-120"/>
+              </a:rPr>
+              <a:t>3. Basis of Time Zones</a:t>
+            </a:r>
+            <a:endParaRPr lang="en-US" sz="3600" dirty="0"/>
+          </a:p>
+        </p:txBody>
+      </p:sp>
+      <p:sp>
+        <p:nvSpPr>
+          <p:cNvPr id="4" name="Text 2"/>
+          <p:cNvSpPr/>
+          <p:nvPr/>
+        </p:nvSpPr>
+        <p:spPr>
+          <a:xfrm>
+            <a:off x="365760" y="1783080"/>
+            <a:ext cx="4846320" cy="4617720"/>
+          </a:xfrm>
+          <a:prstGeom prst="rect">
+            <a:avLst/>
+          </a:prstGeom>
+          <a:noFill/>
+          <a:ln/>
+        </p:spPr>
+        <p:txBody>
+          <a:bodyPr wrap="square" lIns="0" tIns="0" rIns="0" bIns="0" rtlCol="0" anchor="t"/>
+          <a:lstStyle/>
+          <a:p>
+            <a:pPr algn="l" indent="0" marL="0">
+              <a:spcAft>
+                <a:spcPts val="800"/>
+              </a:spcAft>
+              <a:buNone/>
+            </a:pPr>
+            <a:r>
+              <a:rPr lang="en-US" sz="3600" i="1" dirty="0">
+                <a:solidFill>
+                  <a:srgbClr val="111111"/>
+                </a:solidFill>
+                <a:latin typeface="Times New Roman" pitchFamily="34" charset="0"/>
+                <a:ea typeface="Times New Roman" pitchFamily="34" charset="-122"/>
+                <a:cs typeface="Times New Roman" pitchFamily="34" charset="-120"/>
+              </a:rPr>
+              <a:t>Time zones are carved out as follows:</a:t>
+            </a:r>
+            <a:endParaRPr lang="en-US" sz="3600" dirty="0"/>
+          </a:p>
+          <a:p>
+            <a:pPr algn="l" indent="0" marL="0">
+              <a:spcAft>
+                <a:spcPts val="800"/>
+              </a:spcAft>
+              <a:buNone/>
+            </a:pPr>
+            <a:r>
+              <a:rPr lang="en-US" sz="3600" b="1" dirty="0">
+                <a:solidFill>
+                  <a:srgbClr val="111111"/>
+                </a:solidFill>
+                <a:latin typeface="Times New Roman" pitchFamily="34" charset="0"/>
+                <a:ea typeface="Times New Roman" pitchFamily="34" charset="-122"/>
+                <a:cs typeface="Times New Roman" pitchFamily="34" charset="-120"/>
+              </a:rPr>
+              <a:t>24 time zones: </a:t>
+            </a:r>
+            <a:pPr algn="l" indent="0" marL="0">
+              <a:spcAft>
+                <a:spcPts val="800"/>
+              </a:spcAft>
+              <a:buNone/>
+            </a:pPr>
+            <a:r>
+              <a:rPr lang="en-US" sz="3600" dirty="0">
+                <a:solidFill>
+                  <a:srgbClr val="111111"/>
+                </a:solidFill>
+                <a:latin typeface="Times New Roman" pitchFamily="34" charset="0"/>
+                <a:ea typeface="Times New Roman" pitchFamily="34" charset="-122"/>
+                <a:cs typeface="Times New Roman" pitchFamily="34" charset="-120"/>
+              </a:rPr>
+              <a:t>The world is divided into 24 time zones of about 15° each, one for each hour.</a:t>
+            </a:r>
+            <a:endParaRPr lang="en-US" sz="3600" dirty="0"/>
+          </a:p>
+        </p:txBody>
+      </p:sp>
       <p:pic>
         <p:nvPicPr>
-          <p:cNvPr id="3" name="Image 0" descr="/home/claude/f4/img/minesec_sheet.png">    </p:cNvPr>
+          <p:cNvPr id="5" name="Image 0" descr="/home/claude/f4/img/v2/time_zones_big.png">    </p:cNvPr>
           <p:cNvPicPr>
             <a:picLocks noChangeAspect="1"/>
           </p:cNvPicPr>
@@ -15407,8 +15857,8 @@
         </p:blipFill>
         <p:spPr>
           <a:xfrm>
-            <a:off x="0" y="658368"/>
-            <a:ext cx="5120640" cy="5833872"/>
+            <a:off x="5349240" y="2513450"/>
+            <a:ext cx="6659575" cy="2809508"/>
           </a:xfrm>
           <a:prstGeom prst="rect">
             <a:avLst/>
@@ -15417,14 +15867,14 @@
       </p:pic>
       <p:sp>
         <p:nvSpPr>
-          <p:cNvPr id="4" name="Text 1"/>
+          <p:cNvPr id="6" name="Text 3"/>
           <p:cNvSpPr/>
           <p:nvPr/>
         </p:nvSpPr>
         <p:spPr>
           <a:xfrm>
-            <a:off x="5349240" y="1005840"/>
-            <a:ext cx="6522415" cy="731520"/>
+            <a:off x="5349240" y="6089904"/>
+            <a:ext cx="6659575" cy="347472"/>
           </a:xfrm>
           <a:prstGeom prst="rect">
             <a:avLst/>
@@ -15433,85 +15883,24 @@
           <a:ln/>
         </p:spPr>
         <p:txBody>
-          <a:bodyPr wrap="square" lIns="0" tIns="0" rIns="0" bIns="0" rtlCol="0" anchor="ctr">
-            <a:normAutofit/>
-          </a:bodyPr>
+          <a:bodyPr wrap="square" lIns="0" tIns="0" rIns="0" bIns="0" rtlCol="0" anchor="ctr"/>
           <a:lstStyle/>
           <a:p>
             <a:pPr algn="ctr" indent="0" marL="0">
               <a:buNone/>
             </a:pPr>
             <a:r>
-              <a:rPr lang="en-US" sz="3600" b="1" dirty="0">
-                <a:solidFill>
-                  <a:srgbClr val="990011"/>
+              <a:rPr lang="en-US" sz="1600" i="1" dirty="0">
+                <a:solidFill>
+                  <a:srgbClr val="555555"/>
                 </a:solidFill>
                 <a:latin typeface="Times New Roman" pitchFamily="34" charset="0"/>
                 <a:ea typeface="Times New Roman" pitchFamily="34" charset="-122"/>
                 <a:cs typeface="Times New Roman" pitchFamily="34" charset="-120"/>
               </a:rPr>
-              <a:t>2. Time Zones and Cameroon's Standard Time (continued)</a:t>
-            </a:r>
-            <a:endParaRPr lang="en-US" sz="3600" dirty="0"/>
-          </a:p>
-        </p:txBody>
-      </p:sp>
-      <p:sp>
-        <p:nvSpPr>
-          <p:cNvPr id="5" name="Text 2"/>
-          <p:cNvSpPr/>
-          <p:nvPr/>
-        </p:nvSpPr>
-        <p:spPr>
-          <a:xfrm>
-            <a:off x="5349240" y="1783080"/>
-            <a:ext cx="6522415" cy="4663440"/>
-          </a:xfrm>
-          <a:prstGeom prst="rect">
-            <a:avLst/>
-          </a:prstGeom>
-          <a:noFill/>
-          <a:ln/>
-        </p:spPr>
-        <p:txBody>
-          <a:bodyPr wrap="square" lIns="0" tIns="0" rIns="0" bIns="0" rtlCol="0" anchor="t"/>
-          <a:lstStyle/>
-          <a:p>
-            <a:pPr algn="l" indent="0" marL="0">
-              <a:spcAft>
-                <a:spcPts val="800"/>
-              </a:spcAft>
-              <a:buNone/>
-            </a:pPr>
-            <a:r>
-              <a:rPr lang="en-US" sz="4000" b="1" dirty="0">
-                <a:solidFill>
-                  <a:srgbClr val="111111"/>
-                </a:solidFill>
-                <a:latin typeface="Times New Roman" pitchFamily="34" charset="0"/>
-                <a:ea typeface="Times New Roman" pitchFamily="34" charset="-122"/>
-                <a:cs typeface="Times New Roman" pitchFamily="34" charset="-120"/>
-              </a:rPr>
-              <a:t>Comparison: </a:t>
-            </a:r>
-            <a:pPr algn="l" indent="0" marL="0">
-              <a:spcAft>
-                <a:spcPts val="800"/>
-              </a:spcAft>
-              <a:buNone/>
-            </a:pPr>
-            <a:r>
-              <a:rPr lang="en-US" sz="4000" dirty="0">
-                <a:solidFill>
-                  <a:srgbClr val="111111"/>
-                </a:solidFill>
-                <a:latin typeface="Times New Roman" pitchFamily="34" charset="0"/>
-                <a:ea typeface="Times New Roman" pitchFamily="34" charset="-122"/>
-                <a:cs typeface="Times New Roman" pitchFamily="34" charset="-120"/>
-              </a:rPr>
-              <a:t>When it is 12:00 in Cameroon, it is 11:00 in London and 15:00 in Dubai.</a:t>
-            </a:r>
-            <a:endParaRPr lang="en-US" sz="4000" dirty="0"/>
+              <a:t>Illustration: time zones of the world</a:t>
+            </a:r>
+            <a:endParaRPr lang="en-US" sz="1600" dirty="0"/>
           </a:p>
         </p:txBody>
       </p:sp>
@@ -15621,7 +16010,7 @@
                 <a:ea typeface="Calibri" pitchFamily="34" charset="-122"/>
                 <a:cs typeface="Calibri" pitchFamily="34" charset="-120"/>
               </a:rPr>
-              <a:t>FORMATIVE EVALUATION</a:t>
+              <a:t>BOARD SUMMARY</a:t>
             </a:r>
             <a:endParaRPr lang="en-US" sz="1400" dirty="0"/>
           </a:p>
@@ -15686,7 +16075,7 @@
                 <a:ea typeface="Times New Roman" pitchFamily="34" charset="-122"/>
                 <a:cs typeface="Times New Roman" pitchFamily="34" charset="-120"/>
               </a:rPr>
-              <a:t>Evaluation 1</a:t>
+              <a:t>3. Basis of Time Zones</a:t>
             </a:r>
             <a:endParaRPr lang="en-US" sz="3600" dirty="0"/>
           </a:p>
@@ -15720,7 +16109,7 @@
               <a:buNone/>
             </a:pPr>
             <a:r>
-              <a:rPr lang="en-US" sz="4000" dirty="0">
+              <a:rPr lang="en-US" sz="4000" b="1" dirty="0">
                 <a:solidFill>
                   <a:srgbClr val="111111"/>
                 </a:solidFill>
@@ -15728,7 +16117,61 @@
                 <a:ea typeface="Times New Roman" pitchFamily="34" charset="-122"/>
                 <a:cs typeface="Times New Roman" pitchFamily="34" charset="-120"/>
               </a:rPr>
-              <a:t>It is 08:00 GMT. What is the local time at 60° E?</a:t>
+              <a:t>Standard time: </a:t>
+            </a:r>
+            <a:pPr algn="l" indent="0" marL="0">
+              <a:spcAft>
+                <a:spcPts val="800"/>
+              </a:spcAft>
+              <a:buNone/>
+            </a:pPr>
+            <a:r>
+              <a:rPr lang="en-US" sz="4000" dirty="0">
+                <a:solidFill>
+                  <a:srgbClr val="111111"/>
+                </a:solidFill>
+                <a:latin typeface="Times New Roman" pitchFamily="34" charset="0"/>
+                <a:ea typeface="Times New Roman" pitchFamily="34" charset="-122"/>
+                <a:cs typeface="Times New Roman" pitchFamily="34" charset="-120"/>
+              </a:rPr>
+              <a:t>All places in one zone use the same standard time.</a:t>
+            </a:r>
+            <a:endParaRPr lang="en-US" sz="4000" dirty="0"/>
+          </a:p>
+          <a:p>
+            <a:pPr algn="l" indent="0" marL="0">
+              <a:spcAft>
+                <a:spcPts val="800"/>
+              </a:spcAft>
+              <a:buNone/>
+            </a:pPr>
+            <a:r>
+              <a:rPr lang="en-US" sz="4000" b="1" dirty="0">
+                <a:solidFill>
+                  <a:srgbClr val="111111"/>
+                </a:solidFill>
+                <a:latin typeface="Times New Roman" pitchFamily="34" charset="0"/>
+                <a:ea typeface="Times New Roman" pitchFamily="34" charset="-122"/>
+                <a:cs typeface="Times New Roman" pitchFamily="34" charset="-120"/>
+              </a:rPr>
+              <a:t>Boundaries: </a:t>
+            </a:r>
+            <a:pPr algn="l" indent="0" marL="0">
+              <a:spcAft>
+                <a:spcPts val="800"/>
+              </a:spcAft>
+              <a:buNone/>
+            </a:pPr>
+            <a:r>
+              <a:rPr lang="en-US" sz="4000" dirty="0">
+                <a:solidFill>
+                  <a:srgbClr val="111111"/>
+                </a:solidFill>
+                <a:latin typeface="Times New Roman" pitchFamily="34" charset="0"/>
+                <a:ea typeface="Times New Roman" pitchFamily="34" charset="-122"/>
+                <a:cs typeface="Times New Roman" pitchFamily="34" charset="-120"/>
+              </a:rPr>
+              <a:t>The boundaries of the zones often follow the borders of countries.</a:t>
             </a:r>
             <a:endParaRPr lang="en-US" sz="4000" dirty="0"/>
           </a:p>
@@ -15840,15 +16283,135 @@
                 <a:ea typeface="Calibri" pitchFamily="34" charset="-122"/>
                 <a:cs typeface="Calibri" pitchFamily="34" charset="-120"/>
               </a:rPr>
-              <a:t>FORMATIVE EVALUATION</a:t>
+              <a:t>BOARD SUMMARY</a:t>
             </a:r>
             <a:endParaRPr lang="en-US" sz="1400" dirty="0"/>
+          </a:p>
+        </p:txBody>
+      </p:sp>
+      <p:sp>
+        <p:nvSpPr>
+          <p:cNvPr id="3" name="Text 1"/>
+          <p:cNvSpPr/>
+          <p:nvPr/>
+        </p:nvSpPr>
+        <p:spPr>
+          <a:xfrm>
+            <a:off x="365760" y="1005840"/>
+            <a:ext cx="11460175" cy="731520"/>
+          </a:xfrm>
+          <a:prstGeom prst="rect">
+            <a:avLst/>
+          </a:prstGeom>
+          <a:noFill/>
+          <a:ln/>
+        </p:spPr>
+        <p:txBody>
+          <a:bodyPr wrap="square" lIns="0" tIns="0" rIns="0" bIns="0" rtlCol="0" anchor="ctr">
+            <a:normAutofit/>
+          </a:bodyPr>
+          <a:lstStyle/>
+          <a:p>
+            <a:pPr algn="ctr" indent="0" marL="0">
+              <a:buNone/>
+            </a:pPr>
+            <a:r>
+              <a:rPr lang="en-US" sz="3600" b="1" dirty="0">
+                <a:solidFill>
+                  <a:srgbClr val="990011"/>
+                </a:solidFill>
+                <a:latin typeface="Times New Roman" pitchFamily="34" charset="0"/>
+                <a:ea typeface="Times New Roman" pitchFamily="34" charset="-122"/>
+                <a:cs typeface="Times New Roman" pitchFamily="34" charset="-120"/>
+              </a:rPr>
+              <a:t>4. Cameroon's Standard Time and Other Areas</a:t>
+            </a:r>
+            <a:endParaRPr lang="en-US" sz="3600" dirty="0"/>
+          </a:p>
+        </p:txBody>
+      </p:sp>
+      <p:sp>
+        <p:nvSpPr>
+          <p:cNvPr id="4" name="Text 2"/>
+          <p:cNvSpPr/>
+          <p:nvPr/>
+        </p:nvSpPr>
+        <p:spPr>
+          <a:xfrm>
+            <a:off x="365760" y="1783080"/>
+            <a:ext cx="4846320" cy="4617720"/>
+          </a:xfrm>
+          <a:prstGeom prst="rect">
+            <a:avLst/>
+          </a:prstGeom>
+          <a:noFill/>
+          <a:ln/>
+        </p:spPr>
+        <p:txBody>
+          <a:bodyPr wrap="square" lIns="0" tIns="0" rIns="0" bIns="0" rtlCol="0" anchor="t"/>
+          <a:lstStyle/>
+          <a:p>
+            <a:pPr algn="l" indent="0" marL="0">
+              <a:spcAft>
+                <a:spcPts val="800"/>
+              </a:spcAft>
+              <a:buNone/>
+            </a:pPr>
+            <a:r>
+              <a:rPr lang="en-US" sz="3600" i="1" dirty="0">
+                <a:solidFill>
+                  <a:srgbClr val="111111"/>
+                </a:solidFill>
+                <a:latin typeface="Times New Roman" pitchFamily="34" charset="0"/>
+                <a:ea typeface="Times New Roman" pitchFamily="34" charset="-122"/>
+                <a:cs typeface="Times New Roman" pitchFamily="34" charset="-120"/>
+              </a:rPr>
+              <a:t>When it is 12:00 in Cameroon (GMT + 1), the time elsewhere is the following:</a:t>
+            </a:r>
+            <a:endParaRPr lang="en-US" sz="3600" dirty="0"/>
+          </a:p>
+          <a:p>
+            <a:pPr algn="l" indent="0" marL="0">
+              <a:spcAft>
+                <a:spcPts val="800"/>
+              </a:spcAft>
+              <a:buNone/>
+            </a:pPr>
+            <a:r>
+              <a:rPr lang="en-US" sz="3600" b="1" dirty="0">
+                <a:solidFill>
+                  <a:srgbClr val="111111"/>
+                </a:solidFill>
+                <a:latin typeface="Times New Roman" pitchFamily="34" charset="0"/>
+                <a:ea typeface="Times New Roman" pitchFamily="34" charset="-122"/>
+                <a:cs typeface="Times New Roman" pitchFamily="34" charset="-120"/>
+              </a:rPr>
+              <a:t>London (GMT): </a:t>
+            </a:r>
+            <a:pPr algn="l" indent="0" marL="0">
+              <a:spcAft>
+                <a:spcPts val="800"/>
+              </a:spcAft>
+              <a:buNone/>
+            </a:pPr>
+            <a:r>
+              <a:rPr lang="en-US" sz="3600" dirty="0">
+                <a:solidFill>
+                  <a:srgbClr val="111111"/>
+                </a:solidFill>
+                <a:latin typeface="Times New Roman" pitchFamily="34" charset="0"/>
+                <a:ea typeface="Times New Roman" pitchFamily="34" charset="-122"/>
+                <a:cs typeface="Times New Roman" pitchFamily="34" charset="-120"/>
+              </a:rPr>
+              <a:t>It is 11:00.</a:t>
+            </a:r>
+            <a:endParaRPr lang="en-US" sz="3600" dirty="0"/>
           </a:p>
         </p:txBody>
       </p:sp>
       <p:pic>
         <p:nvPicPr>
-          <p:cNvPr id="3" name="Image 0" descr="/home/claude/f4/img/minesec_sheet.png">    </p:cNvPr>
+          <p:cNvPr id="5" name="Image 0" descr="/home/claude/f4/img/v2/f4_worldclocks.jpg">    </p:cNvPr>
           <p:cNvPicPr>
             <a:picLocks noChangeAspect="1"/>
           </p:cNvPicPr>
@@ -15862,8 +16425,8 @@
         </p:blipFill>
         <p:spPr>
           <a:xfrm>
-            <a:off x="0" y="658368"/>
-            <a:ext cx="5120640" cy="5833872"/>
+            <a:off x="5349240" y="2071212"/>
+            <a:ext cx="6659575" cy="3693983"/>
           </a:xfrm>
           <a:prstGeom prst="rect">
             <a:avLst/>
@@ -15872,14 +16435,14 @@
       </p:pic>
       <p:sp>
         <p:nvSpPr>
-          <p:cNvPr id="4" name="Text 1"/>
+          <p:cNvPr id="6" name="Text 3"/>
           <p:cNvSpPr/>
           <p:nvPr/>
         </p:nvSpPr>
         <p:spPr>
           <a:xfrm>
-            <a:off x="5349240" y="1005840"/>
-            <a:ext cx="6522415" cy="731520"/>
+            <a:off x="5349240" y="6089904"/>
+            <a:ext cx="6659575" cy="347472"/>
           </a:xfrm>
           <a:prstGeom prst="rect">
             <a:avLst/>
@@ -15888,68 +16451,24 @@
           <a:ln/>
         </p:spPr>
         <p:txBody>
-          <a:bodyPr wrap="square" lIns="0" tIns="0" rIns="0" bIns="0" rtlCol="0" anchor="ctr">
-            <a:normAutofit/>
-          </a:bodyPr>
+          <a:bodyPr wrap="square" lIns="0" tIns="0" rIns="0" bIns="0" rtlCol="0" anchor="ctr"/>
           <a:lstStyle/>
           <a:p>
             <a:pPr algn="ctr" indent="0" marL="0">
               <a:buNone/>
             </a:pPr>
             <a:r>
-              <a:rPr lang="en-US" sz="3600" b="1" dirty="0">
-                <a:solidFill>
-                  <a:srgbClr val="990011"/>
+              <a:rPr lang="en-US" sz="1600" i="1" dirty="0">
+                <a:solidFill>
+                  <a:srgbClr val="555555"/>
                 </a:solidFill>
                 <a:latin typeface="Times New Roman" pitchFamily="34" charset="0"/>
                 <a:ea typeface="Times New Roman" pitchFamily="34" charset="-122"/>
                 <a:cs typeface="Times New Roman" pitchFamily="34" charset="-120"/>
               </a:rPr>
-              <a:t>Expected Answer</a:t>
-            </a:r>
-            <a:endParaRPr lang="en-US" sz="3600" dirty="0"/>
-          </a:p>
-        </p:txBody>
-      </p:sp>
-      <p:sp>
-        <p:nvSpPr>
-          <p:cNvPr id="5" name="Text 2"/>
-          <p:cNvSpPr/>
-          <p:nvPr/>
-        </p:nvSpPr>
-        <p:spPr>
-          <a:xfrm>
-            <a:off x="5349240" y="1783080"/>
-            <a:ext cx="6522415" cy="4663440"/>
-          </a:xfrm>
-          <a:prstGeom prst="rect">
-            <a:avLst/>
-          </a:prstGeom>
-          <a:noFill/>
-          <a:ln/>
-        </p:spPr>
-        <p:txBody>
-          <a:bodyPr wrap="square" lIns="0" tIns="0" rIns="0" bIns="0" rtlCol="0" anchor="t"/>
-          <a:lstStyle/>
-          <a:p>
-            <a:pPr algn="l" indent="0" marL="0">
-              <a:spcAft>
-                <a:spcPts val="800"/>
-              </a:spcAft>
-              <a:buNone/>
-            </a:pPr>
-            <a:r>
-              <a:rPr lang="en-US" sz="4000" dirty="0">
-                <a:solidFill>
-                  <a:srgbClr val="111111"/>
-                </a:solidFill>
-                <a:latin typeface="Times New Roman" pitchFamily="34" charset="0"/>
-                <a:ea typeface="Times New Roman" pitchFamily="34" charset="-122"/>
-                <a:cs typeface="Times New Roman" pitchFamily="34" charset="-120"/>
-              </a:rPr>
-              <a:t>60 × 4 = 240 min = 4 h; 08:00 + 4 h = 12:00.</a:t>
-            </a:r>
-            <a:endParaRPr lang="en-US" sz="4000" dirty="0"/>
+              <a:t>Illustration: clocks in different cities</a:t>
+            </a:r>
+            <a:endParaRPr lang="en-US" sz="1600" dirty="0"/>
           </a:p>
         </p:txBody>
       </p:sp>
@@ -16059,7 +16578,7 @@
                 <a:ea typeface="Calibri" pitchFamily="34" charset="-122"/>
                 <a:cs typeface="Calibri" pitchFamily="34" charset="-120"/>
               </a:rPr>
-              <a:t>FORMATIVE EVALUATION</a:t>
+              <a:t>BOARD SUMMARY</a:t>
             </a:r>
             <a:endParaRPr lang="en-US" sz="1400" dirty="0"/>
           </a:p>
@@ -16124,7 +16643,7 @@
                 <a:ea typeface="Times New Roman" pitchFamily="34" charset="-122"/>
                 <a:cs typeface="Times New Roman" pitchFamily="34" charset="-120"/>
               </a:rPr>
-              <a:t>Evaluation 2</a:t>
+              <a:t>4. Cameroon's Standard Time and Other Areas</a:t>
             </a:r>
             <a:endParaRPr lang="en-US" sz="3600" dirty="0"/>
           </a:p>
@@ -16158,7 +16677,7 @@
               <a:buNone/>
             </a:pPr>
             <a:r>
-              <a:rPr lang="en-US" sz="4000" dirty="0">
+              <a:rPr lang="en-US" sz="4000" b="1" dirty="0">
                 <a:solidFill>
                   <a:srgbClr val="111111"/>
                 </a:solidFill>
@@ -16166,7 +16685,98 @@
                 <a:ea typeface="Times New Roman" pitchFamily="34" charset="-122"/>
                 <a:cs typeface="Times New Roman" pitchFamily="34" charset="-120"/>
               </a:rPr>
-              <a:t>A match starts at 20:00 in Paris (GMT + 1). What time is it in Cameroon?</a:t>
+              <a:t>Nigeria and Chad (GMT + 1): </a:t>
+            </a:r>
+            <a:pPr algn="l" indent="0" marL="0">
+              <a:spcAft>
+                <a:spcPts val="800"/>
+              </a:spcAft>
+              <a:buNone/>
+            </a:pPr>
+            <a:r>
+              <a:rPr lang="en-US" sz="4000" dirty="0">
+                <a:solidFill>
+                  <a:srgbClr val="111111"/>
+                </a:solidFill>
+                <a:latin typeface="Times New Roman" pitchFamily="34" charset="0"/>
+                <a:ea typeface="Times New Roman" pitchFamily="34" charset="-122"/>
+                <a:cs typeface="Times New Roman" pitchFamily="34" charset="-120"/>
+              </a:rPr>
+              <a:t>It is 12:00, the same time as Cameroon.</a:t>
+            </a:r>
+            <a:endParaRPr lang="en-US" sz="4000" dirty="0"/>
+          </a:p>
+          <a:p>
+            <a:pPr algn="l" indent="0" marL="0">
+              <a:spcAft>
+                <a:spcPts val="800"/>
+              </a:spcAft>
+              <a:buNone/>
+            </a:pPr>
+            <a:r>
+              <a:rPr lang="en-US" sz="4000" b="1" dirty="0">
+                <a:solidFill>
+                  <a:srgbClr val="111111"/>
+                </a:solidFill>
+                <a:latin typeface="Times New Roman" pitchFamily="34" charset="0"/>
+                <a:ea typeface="Times New Roman" pitchFamily="34" charset="-122"/>
+                <a:cs typeface="Times New Roman" pitchFamily="34" charset="-120"/>
+              </a:rPr>
+              <a:t>Dubai (GMT + 4): </a:t>
+            </a:r>
+            <a:pPr algn="l" indent="0" marL="0">
+              <a:spcAft>
+                <a:spcPts val="800"/>
+              </a:spcAft>
+              <a:buNone/>
+            </a:pPr>
+            <a:r>
+              <a:rPr lang="en-US" sz="4000" dirty="0">
+                <a:solidFill>
+                  <a:srgbClr val="111111"/>
+                </a:solidFill>
+                <a:latin typeface="Times New Roman" pitchFamily="34" charset="0"/>
+                <a:ea typeface="Times New Roman" pitchFamily="34" charset="-122"/>
+                <a:cs typeface="Times New Roman" pitchFamily="34" charset="-120"/>
+              </a:rPr>
+              <a:t>It is 15:00.</a:t>
+            </a:r>
+            <a:endParaRPr lang="en-US" sz="4000" dirty="0"/>
+          </a:p>
+          <a:p>
+            <a:pPr algn="l" indent="0" marL="0">
+              <a:spcAft>
+                <a:spcPts val="800"/>
+              </a:spcAft>
+              <a:buNone/>
+            </a:pPr>
+            <a:r>
+              <a:rPr lang="en-US" sz="4000" b="1" dirty="0">
+                <a:solidFill>
+                  <a:srgbClr val="111111"/>
+                </a:solidFill>
+                <a:latin typeface="Times New Roman" pitchFamily="34" charset="0"/>
+                <a:ea typeface="Times New Roman" pitchFamily="34" charset="-122"/>
+                <a:cs typeface="Times New Roman" pitchFamily="34" charset="-120"/>
+              </a:rPr>
+              <a:t>New York (GMT − 5): </a:t>
+            </a:r>
+            <a:pPr algn="l" indent="0" marL="0">
+              <a:spcAft>
+                <a:spcPts val="800"/>
+              </a:spcAft>
+              <a:buNone/>
+            </a:pPr>
+            <a:r>
+              <a:rPr lang="en-US" sz="4000" dirty="0">
+                <a:solidFill>
+                  <a:srgbClr val="111111"/>
+                </a:solidFill>
+                <a:latin typeface="Times New Roman" pitchFamily="34" charset="0"/>
+                <a:ea typeface="Times New Roman" pitchFamily="34" charset="-122"/>
+                <a:cs typeface="Times New Roman" pitchFamily="34" charset="-120"/>
+              </a:rPr>
+              <a:t>It is 06:00.</a:t>
             </a:r>
             <a:endParaRPr lang="en-US" sz="4000" dirty="0"/>
           </a:p>
@@ -16343,7 +16953,7 @@
                 <a:ea typeface="Times New Roman" pitchFamily="34" charset="-122"/>
                 <a:cs typeface="Times New Roman" pitchFamily="34" charset="-120"/>
               </a:rPr>
-              <a:t>Expected Answer</a:t>
+              <a:t>Evaluation 1</a:t>
             </a:r>
             <a:endParaRPr lang="en-US" sz="3600" dirty="0"/>
           </a:p>
@@ -16385,7 +16995,7 @@
                 <a:ea typeface="Times New Roman" pitchFamily="34" charset="-122"/>
                 <a:cs typeface="Times New Roman" pitchFamily="34" charset="-120"/>
               </a:rPr>
-              <a:t>20:00, because both use GMT + 1.</a:t>
+              <a:t>It is 08:00 GMT. What is the local time at 60° E?</a:t>
             </a:r>
             <a:endParaRPr lang="en-US" sz="4000" dirty="0"/>
           </a:p>
@@ -16497,7 +17107,7 @@
                 <a:ea typeface="Calibri" pitchFamily="34" charset="-122"/>
                 <a:cs typeface="Calibri" pitchFamily="34" charset="-120"/>
               </a:rPr>
-              <a:t>REMEDIATION</a:t>
+              <a:t>FORMATIVE EVALUATION</a:t>
             </a:r>
             <a:endParaRPr lang="en-US" sz="1400" dirty="0"/>
           </a:p>
@@ -16520,7 +17130,7 @@
         <p:spPr>
           <a:xfrm>
             <a:off x="0" y="658368"/>
-            <a:ext cx="2468880" cy="5833872"/>
+            <a:ext cx="5120640" cy="5833872"/>
           </a:xfrm>
           <a:prstGeom prst="rect">
             <a:avLst/>
@@ -16535,8 +17145,8 @@
         </p:nvSpPr>
         <p:spPr>
           <a:xfrm>
-            <a:off x="2697480" y="1005840"/>
-            <a:ext cx="9174175" cy="731520"/>
+            <a:off x="5349240" y="1005840"/>
+            <a:ext cx="6522415" cy="731520"/>
           </a:xfrm>
           <a:prstGeom prst="rect">
             <a:avLst/>
@@ -16562,7 +17172,7 @@
                 <a:ea typeface="Times New Roman" pitchFamily="34" charset="-122"/>
                 <a:cs typeface="Times New Roman" pitchFamily="34" charset="-120"/>
               </a:rPr>
-              <a:t>Remediation</a:t>
+              <a:t>Expected Answer</a:t>
             </a:r>
             <a:endParaRPr lang="en-US" sz="3600" dirty="0"/>
           </a:p>
@@ -16576,8 +17186,8 @@
         </p:nvSpPr>
         <p:spPr>
           <a:xfrm>
-            <a:off x="2697480" y="1783080"/>
-            <a:ext cx="9174175" cy="4663440"/>
+            <a:off x="5349240" y="1783080"/>
+            <a:ext cx="6522415" cy="4663440"/>
           </a:xfrm>
           <a:prstGeom prst="rect">
             <a:avLst/>
@@ -16596,7 +17206,7 @@
               <a:buNone/>
             </a:pPr>
             <a:r>
-              <a:rPr lang="en-US" sz="4000" b="1" dirty="0">
+              <a:rPr lang="en-US" sz="4000" dirty="0">
                 <a:solidFill>
                   <a:srgbClr val="111111"/>
                 </a:solidFill>
@@ -16604,73 +17214,7 @@
                 <a:ea typeface="Times New Roman" pitchFamily="34" charset="-122"/>
                 <a:cs typeface="Times New Roman" pitchFamily="34" charset="-120"/>
               </a:rPr>
-              <a:t>Fill in the blanks:</a:t>
-            </a:r>
-            <a:endParaRPr lang="en-US" sz="4000" dirty="0"/>
-          </a:p>
-          <a:p>
-            <a:pPr algn="l" marL="342900" indent="-342900">
-              <a:spcAft>
-                <a:spcPts val="800"/>
-              </a:spcAft>
-              <a:buSzPct val="100000"/>
-              <a:buFont typeface="+mj-lt"/>
-              <a:buAutoNum type="arabicPeriod" startAt="1"/>
-            </a:pPr>
-            <a:r>
-              <a:rPr lang="en-US" sz="4000" dirty="0">
-                <a:solidFill>
-                  <a:srgbClr val="111111"/>
-                </a:solidFill>
-                <a:latin typeface="Times New Roman" pitchFamily="34" charset="0"/>
-                <a:ea typeface="Times New Roman" pitchFamily="34" charset="-122"/>
-                <a:cs typeface="Times New Roman" pitchFamily="34" charset="-120"/>
-              </a:rPr>
-              <a:t>The Earth turns ______° in one hour.</a:t>
-            </a:r>
-            <a:endParaRPr lang="en-US" sz="4000" dirty="0"/>
-          </a:p>
-          <a:p>
-            <a:pPr algn="l" marL="342900" indent="-342900">
-              <a:spcAft>
-                <a:spcPts val="800"/>
-              </a:spcAft>
-              <a:buSzPct val="100000"/>
-              <a:buFont typeface="+mj-lt"/>
-              <a:buAutoNum type="arabicPeriod" startAt="1"/>
-            </a:pPr>
-            <a:r>
-              <a:rPr lang="en-US" sz="4000" dirty="0">
-                <a:solidFill>
-                  <a:srgbClr val="111111"/>
-                </a:solidFill>
-                <a:latin typeface="Times New Roman" pitchFamily="34" charset="0"/>
-                <a:ea typeface="Times New Roman" pitchFamily="34" charset="-122"/>
-                <a:cs typeface="Times New Roman" pitchFamily="34" charset="-120"/>
-              </a:rPr>
-              <a:t>1° of longitude equals ______ minutes.</a:t>
-            </a:r>
-            <a:endParaRPr lang="en-US" sz="4000" dirty="0"/>
-          </a:p>
-          <a:p>
-            <a:pPr algn="l" marL="342900" indent="-342900">
-              <a:spcAft>
-                <a:spcPts val="800"/>
-              </a:spcAft>
-              <a:buSzPct val="100000"/>
-              <a:buFont typeface="+mj-lt"/>
-              <a:buAutoNum type="arabicPeriod" startAt="1"/>
-            </a:pPr>
-            <a:r>
-              <a:rPr lang="en-US" sz="4000" dirty="0">
-                <a:solidFill>
-                  <a:srgbClr val="111111"/>
-                </a:solidFill>
-                <a:latin typeface="Times New Roman" pitchFamily="34" charset="0"/>
-                <a:ea typeface="Times New Roman" pitchFamily="34" charset="-122"/>
-                <a:cs typeface="Times New Roman" pitchFamily="34" charset="-120"/>
-              </a:rPr>
-              <a:t>Places to the ______ are ahead in time.</a:t>
+              <a:t>60 × 4 = 240 min = 4 h; 08:00 + 4 h = 12:00.</a:t>
             </a:r>
             <a:endParaRPr lang="en-US" sz="4000" dirty="0"/>
           </a:p>
@@ -16782,7 +17326,7 @@
                 <a:ea typeface="Calibri" pitchFamily="34" charset="-122"/>
                 <a:cs typeface="Calibri" pitchFamily="34" charset="-120"/>
               </a:rPr>
-              <a:t>HOMEWORK</a:t>
+              <a:t>FORMATIVE EVALUATION</a:t>
             </a:r>
             <a:endParaRPr lang="en-US" sz="1400" dirty="0"/>
           </a:p>
@@ -16847,7 +17391,7 @@
                 <a:ea typeface="Times New Roman" pitchFamily="34" charset="-122"/>
                 <a:cs typeface="Times New Roman" pitchFamily="34" charset="-120"/>
               </a:rPr>
-              <a:t>Homework</a:t>
+              <a:t>Evaluation 2</a:t>
             </a:r>
             <a:endParaRPr lang="en-US" sz="3600" dirty="0"/>
           </a:p>
@@ -16889,7 +17433,7 @@
                 <a:ea typeface="Times New Roman" pitchFamily="34" charset="-122"/>
                 <a:cs typeface="Times New Roman" pitchFamily="34" charset="-120"/>
               </a:rPr>
-              <a:t>When it is 09:00 in Garoua (GMT + 1), what time is it in New York (GMT − 5)?</a:t>
+              <a:t>A match starts at 18:00 in London (GMT). What time is it in Cameroon?</a:t>
             </a:r>
             <a:endParaRPr lang="en-US" sz="4000" dirty="0"/>
           </a:p>
@@ -17001,7 +17545,7 @@
                 <a:ea typeface="Calibri" pitchFamily="34" charset="-122"/>
                 <a:cs typeface="Calibri" pitchFamily="34" charset="-120"/>
               </a:rPr>
-              <a:t>NEXT LESSON</a:t>
+              <a:t>FORMATIVE EVALUATION</a:t>
             </a:r>
             <a:endParaRPr lang="en-US" sz="1400" dirty="0"/>
           </a:p>
@@ -17066,7 +17610,7 @@
                 <a:ea typeface="Times New Roman" pitchFamily="34" charset="-122"/>
                 <a:cs typeface="Times New Roman" pitchFamily="34" charset="-120"/>
               </a:rPr>
-              <a:t>Next Lesson</a:t>
+              <a:t>Expected Answer</a:t>
             </a:r>
             <a:endParaRPr lang="en-US" sz="3600" dirty="0"/>
           </a:p>
@@ -17090,17 +17634,17 @@
           <a:ln/>
         </p:spPr>
         <p:txBody>
-          <a:bodyPr wrap="square" lIns="0" tIns="0" rIns="0" bIns="0" rtlCol="0" anchor="ctr"/>
-          <a:lstStyle/>
-          <a:p>
-            <a:pPr algn="ctr" indent="0" marL="0">
+          <a:bodyPr wrap="square" lIns="0" tIns="0" rIns="0" bIns="0" rtlCol="0" anchor="t"/>
+          <a:lstStyle/>
+          <a:p>
+            <a:pPr algn="l" indent="0" marL="0">
               <a:spcAft>
                 <a:spcPts val="800"/>
               </a:spcAft>
               <a:buNone/>
             </a:pPr>
             <a:r>
-              <a:rPr lang="en-US" sz="4000" b="1" dirty="0">
+              <a:rPr lang="en-US" sz="4000" dirty="0">
                 <a:solidFill>
                   <a:srgbClr val="111111"/>
                 </a:solidFill>
@@ -17108,27 +17652,7 @@
                 <a:ea typeface="Times New Roman" pitchFamily="34" charset="-122"/>
                 <a:cs typeface="Times New Roman" pitchFamily="34" charset="-120"/>
               </a:rPr>
-              <a:t>Our next lesson will be on:</a:t>
-            </a:r>
-            <a:endParaRPr lang="en-US" sz="4000" dirty="0"/>
-          </a:p>
-          <a:p>
-            <a:pPr algn="ctr" indent="0" marL="0">
-              <a:spcAft>
-                <a:spcPts val="800"/>
-              </a:spcAft>
-              <a:buNone/>
-            </a:pPr>
-            <a:r>
-              <a:rPr lang="en-US" sz="4000" b="1" dirty="0">
-                <a:solidFill>
-                  <a:srgbClr val="990011"/>
-                </a:solidFill>
-                <a:latin typeface="Times New Roman" pitchFamily="34" charset="0"/>
-                <a:ea typeface="Times New Roman" pitchFamily="34" charset="-122"/>
-                <a:cs typeface="Times New Roman" pitchFamily="34" charset="-120"/>
-              </a:rPr>
-              <a:t>Lesson 4: The Notion of the Environment</a:t>
+              <a:t>19:00, because Cameroon is GMT + 1.</a:t>
             </a:r>
             <a:endParaRPr lang="en-US" sz="4000" dirty="0"/>
           </a:p>
@@ -17240,6 +17764,968 @@
                 <a:ea typeface="Calibri" pitchFamily="34" charset="-122"/>
                 <a:cs typeface="Calibri" pitchFamily="34" charset="-120"/>
               </a:rPr>
+              <a:t>REMEDIATION</a:t>
+            </a:r>
+            <a:endParaRPr lang="en-US" sz="1400" dirty="0"/>
+          </a:p>
+        </p:txBody>
+      </p:sp>
+      <p:pic>
+        <p:nvPicPr>
+          <p:cNvPr id="3" name="Image 0" descr="/home/claude/f4/img/minesec_sheet.png">    </p:cNvPr>
+          <p:cNvPicPr>
+            <a:picLocks noChangeAspect="1"/>
+          </p:cNvPicPr>
+          <p:nvPr/>
+        </p:nvPicPr>
+        <p:blipFill>
+          <a:blip r:embed="rId1"/>
+          <a:stretch>
+            <a:fillRect/>
+          </a:stretch>
+        </p:blipFill>
+        <p:spPr>
+          <a:xfrm>
+            <a:off x="0" y="658368"/>
+            <a:ext cx="2468880" cy="5833872"/>
+          </a:xfrm>
+          <a:prstGeom prst="rect">
+            <a:avLst/>
+          </a:prstGeom>
+        </p:spPr>
+      </p:pic>
+      <p:sp>
+        <p:nvSpPr>
+          <p:cNvPr id="4" name="Text 1"/>
+          <p:cNvSpPr/>
+          <p:nvPr/>
+        </p:nvSpPr>
+        <p:spPr>
+          <a:xfrm>
+            <a:off x="2697480" y="1005840"/>
+            <a:ext cx="9174175" cy="731520"/>
+          </a:xfrm>
+          <a:prstGeom prst="rect">
+            <a:avLst/>
+          </a:prstGeom>
+          <a:noFill/>
+          <a:ln/>
+        </p:spPr>
+        <p:txBody>
+          <a:bodyPr wrap="square" lIns="0" tIns="0" rIns="0" bIns="0" rtlCol="0" anchor="ctr">
+            <a:normAutofit/>
+          </a:bodyPr>
+          <a:lstStyle/>
+          <a:p>
+            <a:pPr algn="ctr" indent="0" marL="0">
+              <a:buNone/>
+            </a:pPr>
+            <a:r>
+              <a:rPr lang="en-US" sz="3600" b="1" dirty="0">
+                <a:solidFill>
+                  <a:srgbClr val="990011"/>
+                </a:solidFill>
+                <a:latin typeface="Times New Roman" pitchFamily="34" charset="0"/>
+                <a:ea typeface="Times New Roman" pitchFamily="34" charset="-122"/>
+                <a:cs typeface="Times New Roman" pitchFamily="34" charset="-120"/>
+              </a:rPr>
+              <a:t>Remediation</a:t>
+            </a:r>
+            <a:endParaRPr lang="en-US" sz="3600" dirty="0"/>
+          </a:p>
+        </p:txBody>
+      </p:sp>
+      <p:sp>
+        <p:nvSpPr>
+          <p:cNvPr id="5" name="Text 2"/>
+          <p:cNvSpPr/>
+          <p:nvPr/>
+        </p:nvSpPr>
+        <p:spPr>
+          <a:xfrm>
+            <a:off x="2697480" y="1783080"/>
+            <a:ext cx="9174175" cy="4663440"/>
+          </a:xfrm>
+          <a:prstGeom prst="rect">
+            <a:avLst/>
+          </a:prstGeom>
+          <a:noFill/>
+          <a:ln/>
+        </p:spPr>
+        <p:txBody>
+          <a:bodyPr wrap="square" lIns="0" tIns="0" rIns="0" bIns="0" rtlCol="0" anchor="t"/>
+          <a:lstStyle/>
+          <a:p>
+            <a:pPr algn="l" indent="0" marL="0">
+              <a:spcAft>
+                <a:spcPts val="800"/>
+              </a:spcAft>
+              <a:buNone/>
+            </a:pPr>
+            <a:r>
+              <a:rPr lang="en-US" sz="4000" b="1" dirty="0">
+                <a:solidFill>
+                  <a:srgbClr val="111111"/>
+                </a:solidFill>
+                <a:latin typeface="Times New Roman" pitchFamily="34" charset="0"/>
+                <a:ea typeface="Times New Roman" pitchFamily="34" charset="-122"/>
+                <a:cs typeface="Times New Roman" pitchFamily="34" charset="-120"/>
+              </a:rPr>
+              <a:t>Fill in the blanks:</a:t>
+            </a:r>
+            <a:endParaRPr lang="en-US" sz="4000" dirty="0"/>
+          </a:p>
+          <a:p>
+            <a:pPr algn="l" marL="342900" indent="-342900">
+              <a:spcAft>
+                <a:spcPts val="800"/>
+              </a:spcAft>
+              <a:buSzPct val="100000"/>
+              <a:buFont typeface="+mj-lt"/>
+              <a:buAutoNum type="arabicPeriod" startAt="1"/>
+            </a:pPr>
+            <a:r>
+              <a:rPr lang="en-US" sz="4000" dirty="0">
+                <a:solidFill>
+                  <a:srgbClr val="111111"/>
+                </a:solidFill>
+                <a:latin typeface="Times New Roman" pitchFamily="34" charset="0"/>
+                <a:ea typeface="Times New Roman" pitchFamily="34" charset="-122"/>
+                <a:cs typeface="Times New Roman" pitchFamily="34" charset="-120"/>
+              </a:rPr>
+              <a:t>The Earth turns ______° in one hour.</a:t>
+            </a:r>
+            <a:endParaRPr lang="en-US" sz="4000" dirty="0"/>
+          </a:p>
+          <a:p>
+            <a:pPr algn="l" marL="342900" indent="-342900">
+              <a:spcAft>
+                <a:spcPts val="800"/>
+              </a:spcAft>
+              <a:buSzPct val="100000"/>
+              <a:buFont typeface="+mj-lt"/>
+              <a:buAutoNum type="arabicPeriod" startAt="1"/>
+            </a:pPr>
+            <a:r>
+              <a:rPr lang="en-US" sz="4000" dirty="0">
+                <a:solidFill>
+                  <a:srgbClr val="111111"/>
+                </a:solidFill>
+                <a:latin typeface="Times New Roman" pitchFamily="34" charset="0"/>
+                <a:ea typeface="Times New Roman" pitchFamily="34" charset="-122"/>
+                <a:cs typeface="Times New Roman" pitchFamily="34" charset="-120"/>
+              </a:rPr>
+              <a:t>1° of longitude equals ______ minutes.</a:t>
+            </a:r>
+            <a:endParaRPr lang="en-US" sz="4000" dirty="0"/>
+          </a:p>
+          <a:p>
+            <a:pPr algn="l" marL="342900" indent="-342900">
+              <a:spcAft>
+                <a:spcPts val="800"/>
+              </a:spcAft>
+              <a:buSzPct val="100000"/>
+              <a:buFont typeface="+mj-lt"/>
+              <a:buAutoNum type="arabicPeriod" startAt="1"/>
+            </a:pPr>
+            <a:r>
+              <a:rPr lang="en-US" sz="4000" dirty="0">
+                <a:solidFill>
+                  <a:srgbClr val="111111"/>
+                </a:solidFill>
+                <a:latin typeface="Times New Roman" pitchFamily="34" charset="0"/>
+                <a:ea typeface="Times New Roman" pitchFamily="34" charset="-122"/>
+                <a:cs typeface="Times New Roman" pitchFamily="34" charset="-120"/>
+              </a:rPr>
+              <a:t>Places to the ______ are ahead in time.</a:t>
+            </a:r>
+            <a:endParaRPr lang="en-US" sz="4000" dirty="0"/>
+          </a:p>
+        </p:txBody>
+      </p:sp>
+      <p:sp>
+        <p:nvSpPr>
+          <p:cNvPr id="25" name="Slide Number Placeholder 0"/>
+          <p:cNvSpPr>
+            <a:spLocks noGrp="1"/>
+          </p:cNvSpPr>
+          <p:nvPr>
+            <p:ph type="sldNum" sz="quarter" idx="4294967295"/>
+          </p:nvPr>
+        </p:nvSpPr>
+        <p:spPr>
+          <a:xfrm>
+            <a:off x="27432" y="91440"/>
+            <a:ext cx="585216" cy="475488"/>
+          </a:xfrm>
+          <a:prstGeom prst="rect">
+            <a:avLst/>
+          </a:prstGeom>
+          <a:extLst>
+            <a:ext uri="{C572A759-6A51-4108-AA02-DFA0A04FC94B}">
+              <ma14:wrappingTextBoxFlag xmlns:ma14="http://schemas.microsoft.com/office/mac/drawingml/2011/main" val="0"/>
+            </a:ext>
+          </a:extLst>
+        </p:spPr>
+        <p:txBody>
+          <a:bodyPr/>
+          <a:lstStyle>
+            <a:lvl1pPr>
+              <a:defRPr sz="2000">
+                <a:solidFill>
+                  <a:srgbClr val="FFFFFF"/>
+                </a:solidFill>
+                <a:latin typeface="Calibri"/>
+                <a:ea typeface="Calibri"/>
+                <a:cs typeface="Calibri"/>
+              </a:defRPr>
+            </a:lvl1pPr>
+          </a:lstStyle>
+          <a:p>
+            <a:pPr algn="ctr"/>
+            <a:fld id="{F7021451-1387-4CA6-816F-3879F97B5CBC}" type="slidenum">
+              <a:rPr b="1" lang="en-US"/>
+              <a:t>49</a:t>
+            </a:fld>
+            <a:endParaRPr lang="en-US"/>
+          </a:p>
+        </p:txBody>
+      </p:sp>
+    </p:spTree>
+  </p:cSld>
+  <p:clrMapOvr>
+    <a:masterClrMapping/>
+  </p:clrMapOvr>
+</p:sld>
+</file>
+
+<file path=ppt/slides/slide5.xml><?xml version="1.0" encoding="utf-8"?>
+<p:sld xmlns:a="http://schemas.openxmlformats.org/drawingml/2006/main" xmlns:r="http://schemas.openxmlformats.org/officeDocument/2006/relationships" xmlns:p="http://schemas.openxmlformats.org/presentationml/2006/main">
+  <p:cSld name="Slide 5">
+    <p:spTree>
+      <p:nvGrpSpPr>
+        <p:cNvPr id="1" name=""/>
+        <p:cNvGrpSpPr/>
+        <p:nvPr/>
+      </p:nvGrpSpPr>
+      <p:grpSpPr>
+        <a:xfrm>
+          <a:off x="0" y="0"/>
+          <a:ext cx="0" cy="0"/>
+          <a:chOff x="0" y="0"/>
+          <a:chExt cx="0" cy="0"/>
+        </a:xfrm>
+      </p:grpSpPr>
+      <p:sp>
+        <p:nvSpPr>
+          <p:cNvPr id="2" name="Text 0"/>
+          <p:cNvSpPr/>
+          <p:nvPr/>
+        </p:nvSpPr>
+        <p:spPr>
+          <a:xfrm>
+            <a:off x="457200" y="713232"/>
+            <a:ext cx="11368735" cy="274320"/>
+          </a:xfrm>
+          <a:prstGeom prst="rect">
+            <a:avLst/>
+          </a:prstGeom>
+          <a:noFill/>
+          <a:ln/>
+        </p:spPr>
+        <p:txBody>
+          <a:bodyPr wrap="square" lIns="0" tIns="0" rIns="0" bIns="0" rtlCol="0" anchor="ctr"/>
+          <a:lstStyle/>
+          <a:p>
+            <a:pPr algn="r" indent="0" marL="0">
+              <a:buNone/>
+            </a:pPr>
+            <a:r>
+              <a:rPr lang="en-US" sz="1400" b="1" dirty="0">
+                <a:solidFill>
+                  <a:srgbClr val="1C3F6E"/>
+                </a:solidFill>
+                <a:latin typeface="Calibri" pitchFamily="34" charset="0"/>
+                <a:ea typeface="Calibri" pitchFamily="34" charset="-122"/>
+                <a:cs typeface="Calibri" pitchFamily="34" charset="-120"/>
+              </a:rPr>
+              <a:t>HOMEWORK CORRECTION</a:t>
+            </a:r>
+            <a:endParaRPr lang="en-US" sz="1400" dirty="0"/>
+          </a:p>
+        </p:txBody>
+      </p:sp>
+      <p:pic>
+        <p:nvPicPr>
+          <p:cNvPr id="3" name="Image 0" descr="/home/claude/f4/img/minesec_sheet.png">    </p:cNvPr>
+          <p:cNvPicPr>
+            <a:picLocks noChangeAspect="1"/>
+          </p:cNvPicPr>
+          <p:nvPr/>
+        </p:nvPicPr>
+        <p:blipFill>
+          <a:blip r:embed="rId1"/>
+          <a:stretch>
+            <a:fillRect/>
+          </a:stretch>
+        </p:blipFill>
+        <p:spPr>
+          <a:xfrm>
+            <a:off x="0" y="658368"/>
+            <a:ext cx="5120640" cy="5833872"/>
+          </a:xfrm>
+          <a:prstGeom prst="rect">
+            <a:avLst/>
+          </a:prstGeom>
+        </p:spPr>
+      </p:pic>
+      <p:sp>
+        <p:nvSpPr>
+          <p:cNvPr id="4" name="Text 1"/>
+          <p:cNvSpPr/>
+          <p:nvPr/>
+        </p:nvSpPr>
+        <p:spPr>
+          <a:xfrm>
+            <a:off x="5349240" y="1005840"/>
+            <a:ext cx="6522415" cy="731520"/>
+          </a:xfrm>
+          <a:prstGeom prst="rect">
+            <a:avLst/>
+          </a:prstGeom>
+          <a:noFill/>
+          <a:ln/>
+        </p:spPr>
+        <p:txBody>
+          <a:bodyPr wrap="square" lIns="0" tIns="0" rIns="0" bIns="0" rtlCol="0" anchor="ctr">
+            <a:normAutofit/>
+          </a:bodyPr>
+          <a:lstStyle/>
+          <a:p>
+            <a:pPr algn="ctr" indent="0" marL="0">
+              <a:buNone/>
+            </a:pPr>
+            <a:r>
+              <a:rPr lang="en-US" sz="3600" b="1" dirty="0">
+                <a:solidFill>
+                  <a:srgbClr val="990011"/>
+                </a:solidFill>
+                <a:latin typeface="Times New Roman" pitchFamily="34" charset="0"/>
+                <a:ea typeface="Times New Roman" pitchFamily="34" charset="-122"/>
+                <a:cs typeface="Times New Roman" pitchFamily="34" charset="-120"/>
+              </a:rPr>
+              <a:t>Correction: Possible Answer</a:t>
+            </a:r>
+            <a:endParaRPr lang="en-US" sz="3600" dirty="0"/>
+          </a:p>
+        </p:txBody>
+      </p:sp>
+      <p:sp>
+        <p:nvSpPr>
+          <p:cNvPr id="5" name="Text 2"/>
+          <p:cNvSpPr/>
+          <p:nvPr/>
+        </p:nvSpPr>
+        <p:spPr>
+          <a:xfrm>
+            <a:off x="5349240" y="1783080"/>
+            <a:ext cx="6522415" cy="4663440"/>
+          </a:xfrm>
+          <a:prstGeom prst="rect">
+            <a:avLst/>
+          </a:prstGeom>
+          <a:noFill/>
+          <a:ln/>
+        </p:spPr>
+        <p:txBody>
+          <a:bodyPr wrap="square" lIns="0" tIns="0" rIns="0" bIns="0" rtlCol="0" anchor="t"/>
+          <a:lstStyle/>
+          <a:p>
+            <a:pPr algn="l" indent="0" marL="0">
+              <a:spcAft>
+                <a:spcPts val="800"/>
+              </a:spcAft>
+              <a:buNone/>
+            </a:pPr>
+            <a:r>
+              <a:rPr lang="en-US" sz="4000" dirty="0">
+                <a:solidFill>
+                  <a:srgbClr val="111111"/>
+                </a:solidFill>
+                <a:latin typeface="Times New Roman" pitchFamily="34" charset="0"/>
+                <a:ea typeface="Times New Roman" pitchFamily="34" charset="-122"/>
+                <a:cs typeface="Times New Roman" pitchFamily="34" charset="-120"/>
+              </a:rPr>
+              <a:t>Garoua is 15° east of London, so it is 1 hour ahead: 12:00 + 1 hour = 13:00.</a:t>
+            </a:r>
+            <a:endParaRPr lang="en-US" sz="4000" dirty="0"/>
+          </a:p>
+        </p:txBody>
+      </p:sp>
+      <p:sp>
+        <p:nvSpPr>
+          <p:cNvPr id="25" name="Slide Number Placeholder 0"/>
+          <p:cNvSpPr>
+            <a:spLocks noGrp="1"/>
+          </p:cNvSpPr>
+          <p:nvPr>
+            <p:ph type="sldNum" sz="quarter" idx="4294967295"/>
+          </p:nvPr>
+        </p:nvSpPr>
+        <p:spPr>
+          <a:xfrm>
+            <a:off x="27432" y="91440"/>
+            <a:ext cx="585216" cy="475488"/>
+          </a:xfrm>
+          <a:prstGeom prst="rect">
+            <a:avLst/>
+          </a:prstGeom>
+          <a:extLst>
+            <a:ext uri="{C572A759-6A51-4108-AA02-DFA0A04FC94B}">
+              <ma14:wrappingTextBoxFlag xmlns:ma14="http://schemas.microsoft.com/office/mac/drawingml/2011/main" val="0"/>
+            </a:ext>
+          </a:extLst>
+        </p:spPr>
+        <p:txBody>
+          <a:bodyPr/>
+          <a:lstStyle>
+            <a:lvl1pPr>
+              <a:defRPr sz="2000">
+                <a:solidFill>
+                  <a:srgbClr val="FFFFFF"/>
+                </a:solidFill>
+                <a:latin typeface="Calibri"/>
+                <a:ea typeface="Calibri"/>
+                <a:cs typeface="Calibri"/>
+              </a:defRPr>
+            </a:lvl1pPr>
+          </a:lstStyle>
+          <a:p>
+            <a:pPr algn="ctr"/>
+            <a:fld id="{F7021451-1387-4CA6-816F-3879F97B5CBC}" type="slidenum">
+              <a:rPr b="1" lang="en-US"/>
+              <a:t>5</a:t>
+            </a:fld>
+            <a:endParaRPr lang="en-US"/>
+          </a:p>
+        </p:txBody>
+      </p:sp>
+    </p:spTree>
+  </p:cSld>
+  <p:clrMapOvr>
+    <a:masterClrMapping/>
+  </p:clrMapOvr>
+</p:sld>
+</file>
+
+<file path=ppt/slides/slide50.xml><?xml version="1.0" encoding="utf-8"?>
+<p:sld xmlns:a="http://schemas.openxmlformats.org/drawingml/2006/main" xmlns:r="http://schemas.openxmlformats.org/officeDocument/2006/relationships" xmlns:p="http://schemas.openxmlformats.org/presentationml/2006/main">
+  <p:cSld name="Slide 50">
+    <p:spTree>
+      <p:nvGrpSpPr>
+        <p:cNvPr id="1" name=""/>
+        <p:cNvGrpSpPr/>
+        <p:nvPr/>
+      </p:nvGrpSpPr>
+      <p:grpSpPr>
+        <a:xfrm>
+          <a:off x="0" y="0"/>
+          <a:ext cx="0" cy="0"/>
+          <a:chOff x="0" y="0"/>
+          <a:chExt cx="0" cy="0"/>
+        </a:xfrm>
+      </p:grpSpPr>
+      <p:sp>
+        <p:nvSpPr>
+          <p:cNvPr id="2" name="Text 0"/>
+          <p:cNvSpPr/>
+          <p:nvPr/>
+        </p:nvSpPr>
+        <p:spPr>
+          <a:xfrm>
+            <a:off x="457200" y="713232"/>
+            <a:ext cx="11368735" cy="274320"/>
+          </a:xfrm>
+          <a:prstGeom prst="rect">
+            <a:avLst/>
+          </a:prstGeom>
+          <a:noFill/>
+          <a:ln/>
+        </p:spPr>
+        <p:txBody>
+          <a:bodyPr wrap="square" lIns="0" tIns="0" rIns="0" bIns="0" rtlCol="0" anchor="ctr"/>
+          <a:lstStyle/>
+          <a:p>
+            <a:pPr algn="r" indent="0" marL="0">
+              <a:buNone/>
+            </a:pPr>
+            <a:r>
+              <a:rPr lang="en-US" sz="1400" b="1" dirty="0">
+                <a:solidFill>
+                  <a:srgbClr val="1C3F6E"/>
+                </a:solidFill>
+                <a:latin typeface="Calibri" pitchFamily="34" charset="0"/>
+                <a:ea typeface="Calibri" pitchFamily="34" charset="-122"/>
+                <a:cs typeface="Calibri" pitchFamily="34" charset="-120"/>
+              </a:rPr>
+              <a:t>HOMEWORK</a:t>
+            </a:r>
+            <a:endParaRPr lang="en-US" sz="1400" dirty="0"/>
+          </a:p>
+        </p:txBody>
+      </p:sp>
+      <p:pic>
+        <p:nvPicPr>
+          <p:cNvPr id="3" name="Image 0" descr="/home/claude/f4/img/minesec_sheet.png">    </p:cNvPr>
+          <p:cNvPicPr>
+            <a:picLocks noChangeAspect="1"/>
+          </p:cNvPicPr>
+          <p:nvPr/>
+        </p:nvPicPr>
+        <p:blipFill>
+          <a:blip r:embed="rId1"/>
+          <a:stretch>
+            <a:fillRect/>
+          </a:stretch>
+        </p:blipFill>
+        <p:spPr>
+          <a:xfrm>
+            <a:off x="0" y="658368"/>
+            <a:ext cx="5120640" cy="5833872"/>
+          </a:xfrm>
+          <a:prstGeom prst="rect">
+            <a:avLst/>
+          </a:prstGeom>
+        </p:spPr>
+      </p:pic>
+      <p:sp>
+        <p:nvSpPr>
+          <p:cNvPr id="4" name="Text 1"/>
+          <p:cNvSpPr/>
+          <p:nvPr/>
+        </p:nvSpPr>
+        <p:spPr>
+          <a:xfrm>
+            <a:off x="5349240" y="1005840"/>
+            <a:ext cx="6522415" cy="731520"/>
+          </a:xfrm>
+          <a:prstGeom prst="rect">
+            <a:avLst/>
+          </a:prstGeom>
+          <a:noFill/>
+          <a:ln/>
+        </p:spPr>
+        <p:txBody>
+          <a:bodyPr wrap="square" lIns="0" tIns="0" rIns="0" bIns="0" rtlCol="0" anchor="ctr">
+            <a:normAutofit/>
+          </a:bodyPr>
+          <a:lstStyle/>
+          <a:p>
+            <a:pPr algn="ctr" indent="0" marL="0">
+              <a:buNone/>
+            </a:pPr>
+            <a:r>
+              <a:rPr lang="en-US" sz="3600" b="1" dirty="0">
+                <a:solidFill>
+                  <a:srgbClr val="990011"/>
+                </a:solidFill>
+                <a:latin typeface="Times New Roman" pitchFamily="34" charset="0"/>
+                <a:ea typeface="Times New Roman" pitchFamily="34" charset="-122"/>
+                <a:cs typeface="Times New Roman" pitchFamily="34" charset="-120"/>
+              </a:rPr>
+              <a:t>Homework</a:t>
+            </a:r>
+            <a:endParaRPr lang="en-US" sz="3600" dirty="0"/>
+          </a:p>
+        </p:txBody>
+      </p:sp>
+      <p:sp>
+        <p:nvSpPr>
+          <p:cNvPr id="5" name="Text 2"/>
+          <p:cNvSpPr/>
+          <p:nvPr/>
+        </p:nvSpPr>
+        <p:spPr>
+          <a:xfrm>
+            <a:off x="5349240" y="1783080"/>
+            <a:ext cx="6522415" cy="4663440"/>
+          </a:xfrm>
+          <a:prstGeom prst="rect">
+            <a:avLst/>
+          </a:prstGeom>
+          <a:noFill/>
+          <a:ln/>
+        </p:spPr>
+        <p:txBody>
+          <a:bodyPr wrap="square" lIns="0" tIns="0" rIns="0" bIns="0" rtlCol="0" anchor="t"/>
+          <a:lstStyle/>
+          <a:p>
+            <a:pPr algn="l" indent="0" marL="0">
+              <a:spcAft>
+                <a:spcPts val="800"/>
+              </a:spcAft>
+              <a:buNone/>
+            </a:pPr>
+            <a:r>
+              <a:rPr lang="en-US" sz="4000" dirty="0">
+                <a:solidFill>
+                  <a:srgbClr val="111111"/>
+                </a:solidFill>
+                <a:latin typeface="Times New Roman" pitchFamily="34" charset="0"/>
+                <a:ea typeface="Times New Roman" pitchFamily="34" charset="-122"/>
+                <a:cs typeface="Times New Roman" pitchFamily="34" charset="-120"/>
+              </a:rPr>
+              <a:t>When it is 09:00 in Garoua (GMT + 1), what time is it in New York (GMT − 5)?</a:t>
+            </a:r>
+            <a:endParaRPr lang="en-US" sz="4000" dirty="0"/>
+          </a:p>
+        </p:txBody>
+      </p:sp>
+      <p:sp>
+        <p:nvSpPr>
+          <p:cNvPr id="25" name="Slide Number Placeholder 0"/>
+          <p:cNvSpPr>
+            <a:spLocks noGrp="1"/>
+          </p:cNvSpPr>
+          <p:nvPr>
+            <p:ph type="sldNum" sz="quarter" idx="4294967295"/>
+          </p:nvPr>
+        </p:nvSpPr>
+        <p:spPr>
+          <a:xfrm>
+            <a:off x="27432" y="91440"/>
+            <a:ext cx="585216" cy="475488"/>
+          </a:xfrm>
+          <a:prstGeom prst="rect">
+            <a:avLst/>
+          </a:prstGeom>
+          <a:extLst>
+            <a:ext uri="{C572A759-6A51-4108-AA02-DFA0A04FC94B}">
+              <ma14:wrappingTextBoxFlag xmlns:ma14="http://schemas.microsoft.com/office/mac/drawingml/2011/main" val="0"/>
+            </a:ext>
+          </a:extLst>
+        </p:spPr>
+        <p:txBody>
+          <a:bodyPr/>
+          <a:lstStyle>
+            <a:lvl1pPr>
+              <a:defRPr sz="2000">
+                <a:solidFill>
+                  <a:srgbClr val="FFFFFF"/>
+                </a:solidFill>
+                <a:latin typeface="Calibri"/>
+                <a:ea typeface="Calibri"/>
+                <a:cs typeface="Calibri"/>
+              </a:defRPr>
+            </a:lvl1pPr>
+          </a:lstStyle>
+          <a:p>
+            <a:pPr algn="ctr"/>
+            <a:fld id="{F7021451-1387-4CA6-816F-3879F97B5CBC}" type="slidenum">
+              <a:rPr b="1" lang="en-US"/>
+              <a:t>50</a:t>
+            </a:fld>
+            <a:endParaRPr lang="en-US"/>
+          </a:p>
+        </p:txBody>
+      </p:sp>
+    </p:spTree>
+  </p:cSld>
+  <p:clrMapOvr>
+    <a:masterClrMapping/>
+  </p:clrMapOvr>
+</p:sld>
+</file>
+
+<file path=ppt/slides/slide51.xml><?xml version="1.0" encoding="utf-8"?>
+<p:sld xmlns:a="http://schemas.openxmlformats.org/drawingml/2006/main" xmlns:r="http://schemas.openxmlformats.org/officeDocument/2006/relationships" xmlns:p="http://schemas.openxmlformats.org/presentationml/2006/main">
+  <p:cSld name="Slide 51">
+    <p:spTree>
+      <p:nvGrpSpPr>
+        <p:cNvPr id="1" name=""/>
+        <p:cNvGrpSpPr/>
+        <p:nvPr/>
+      </p:nvGrpSpPr>
+      <p:grpSpPr>
+        <a:xfrm>
+          <a:off x="0" y="0"/>
+          <a:ext cx="0" cy="0"/>
+          <a:chOff x="0" y="0"/>
+          <a:chExt cx="0" cy="0"/>
+        </a:xfrm>
+      </p:grpSpPr>
+      <p:sp>
+        <p:nvSpPr>
+          <p:cNvPr id="2" name="Text 0"/>
+          <p:cNvSpPr/>
+          <p:nvPr/>
+        </p:nvSpPr>
+        <p:spPr>
+          <a:xfrm>
+            <a:off x="457200" y="713232"/>
+            <a:ext cx="11368735" cy="274320"/>
+          </a:xfrm>
+          <a:prstGeom prst="rect">
+            <a:avLst/>
+          </a:prstGeom>
+          <a:noFill/>
+          <a:ln/>
+        </p:spPr>
+        <p:txBody>
+          <a:bodyPr wrap="square" lIns="0" tIns="0" rIns="0" bIns="0" rtlCol="0" anchor="ctr"/>
+          <a:lstStyle/>
+          <a:p>
+            <a:pPr algn="r" indent="0" marL="0">
+              <a:buNone/>
+            </a:pPr>
+            <a:r>
+              <a:rPr lang="en-US" sz="1400" b="1" dirty="0">
+                <a:solidFill>
+                  <a:srgbClr val="1C3F6E"/>
+                </a:solidFill>
+                <a:latin typeface="Calibri" pitchFamily="34" charset="0"/>
+                <a:ea typeface="Calibri" pitchFamily="34" charset="-122"/>
+                <a:cs typeface="Calibri" pitchFamily="34" charset="-120"/>
+              </a:rPr>
+              <a:t>NEXT LESSON</a:t>
+            </a:r>
+            <a:endParaRPr lang="en-US" sz="1400" dirty="0"/>
+          </a:p>
+        </p:txBody>
+      </p:sp>
+      <p:pic>
+        <p:nvPicPr>
+          <p:cNvPr id="3" name="Image 0" descr="/home/claude/f4/img/minesec_sheet.png">    </p:cNvPr>
+          <p:cNvPicPr>
+            <a:picLocks noChangeAspect="1"/>
+          </p:cNvPicPr>
+          <p:nvPr/>
+        </p:nvPicPr>
+        <p:blipFill>
+          <a:blip r:embed="rId1"/>
+          <a:stretch>
+            <a:fillRect/>
+          </a:stretch>
+        </p:blipFill>
+        <p:spPr>
+          <a:xfrm>
+            <a:off x="0" y="658368"/>
+            <a:ext cx="5120640" cy="5833872"/>
+          </a:xfrm>
+          <a:prstGeom prst="rect">
+            <a:avLst/>
+          </a:prstGeom>
+        </p:spPr>
+      </p:pic>
+      <p:sp>
+        <p:nvSpPr>
+          <p:cNvPr id="4" name="Text 1"/>
+          <p:cNvSpPr/>
+          <p:nvPr/>
+        </p:nvSpPr>
+        <p:spPr>
+          <a:xfrm>
+            <a:off x="5349240" y="1005840"/>
+            <a:ext cx="6522415" cy="731520"/>
+          </a:xfrm>
+          <a:prstGeom prst="rect">
+            <a:avLst/>
+          </a:prstGeom>
+          <a:noFill/>
+          <a:ln/>
+        </p:spPr>
+        <p:txBody>
+          <a:bodyPr wrap="square" lIns="0" tIns="0" rIns="0" bIns="0" rtlCol="0" anchor="ctr">
+            <a:normAutofit/>
+          </a:bodyPr>
+          <a:lstStyle/>
+          <a:p>
+            <a:pPr algn="ctr" indent="0" marL="0">
+              <a:buNone/>
+            </a:pPr>
+            <a:r>
+              <a:rPr lang="en-US" sz="3600" b="1" dirty="0">
+                <a:solidFill>
+                  <a:srgbClr val="990011"/>
+                </a:solidFill>
+                <a:latin typeface="Times New Roman" pitchFamily="34" charset="0"/>
+                <a:ea typeface="Times New Roman" pitchFamily="34" charset="-122"/>
+                <a:cs typeface="Times New Roman" pitchFamily="34" charset="-120"/>
+              </a:rPr>
+              <a:t>Next Lesson</a:t>
+            </a:r>
+            <a:endParaRPr lang="en-US" sz="3600" dirty="0"/>
+          </a:p>
+        </p:txBody>
+      </p:sp>
+      <p:sp>
+        <p:nvSpPr>
+          <p:cNvPr id="5" name="Text 2"/>
+          <p:cNvSpPr/>
+          <p:nvPr/>
+        </p:nvSpPr>
+        <p:spPr>
+          <a:xfrm>
+            <a:off x="5349240" y="1783080"/>
+            <a:ext cx="6522415" cy="4663440"/>
+          </a:xfrm>
+          <a:prstGeom prst="rect">
+            <a:avLst/>
+          </a:prstGeom>
+          <a:noFill/>
+          <a:ln/>
+        </p:spPr>
+        <p:txBody>
+          <a:bodyPr wrap="square" lIns="0" tIns="0" rIns="0" bIns="0" rtlCol="0" anchor="ctr"/>
+          <a:lstStyle/>
+          <a:p>
+            <a:pPr algn="ctr" indent="0" marL="0">
+              <a:spcAft>
+                <a:spcPts val="800"/>
+              </a:spcAft>
+              <a:buNone/>
+            </a:pPr>
+            <a:r>
+              <a:rPr lang="en-US" sz="4000" b="1" dirty="0">
+                <a:solidFill>
+                  <a:srgbClr val="111111"/>
+                </a:solidFill>
+                <a:latin typeface="Times New Roman" pitchFamily="34" charset="0"/>
+                <a:ea typeface="Times New Roman" pitchFamily="34" charset="-122"/>
+                <a:cs typeface="Times New Roman" pitchFamily="34" charset="-120"/>
+              </a:rPr>
+              <a:t>Our next lesson will be on:</a:t>
+            </a:r>
+            <a:endParaRPr lang="en-US" sz="4000" dirty="0"/>
+          </a:p>
+          <a:p>
+            <a:pPr algn="ctr" indent="0" marL="0">
+              <a:spcAft>
+                <a:spcPts val="800"/>
+              </a:spcAft>
+              <a:buNone/>
+            </a:pPr>
+            <a:r>
+              <a:rPr lang="en-US" sz="4000" b="1" dirty="0">
+                <a:solidFill>
+                  <a:srgbClr val="990011"/>
+                </a:solidFill>
+                <a:latin typeface="Times New Roman" pitchFamily="34" charset="0"/>
+                <a:ea typeface="Times New Roman" pitchFamily="34" charset="-122"/>
+                <a:cs typeface="Times New Roman" pitchFamily="34" charset="-120"/>
+              </a:rPr>
+              <a:t>Lesson 4: The Notion of the Environment</a:t>
+            </a:r>
+            <a:endParaRPr lang="en-US" sz="4000" dirty="0"/>
+          </a:p>
+        </p:txBody>
+      </p:sp>
+      <p:sp>
+        <p:nvSpPr>
+          <p:cNvPr id="25" name="Slide Number Placeholder 0"/>
+          <p:cNvSpPr>
+            <a:spLocks noGrp="1"/>
+          </p:cNvSpPr>
+          <p:nvPr>
+            <p:ph type="sldNum" sz="quarter" idx="4294967295"/>
+          </p:nvPr>
+        </p:nvSpPr>
+        <p:spPr>
+          <a:xfrm>
+            <a:off x="27432" y="91440"/>
+            <a:ext cx="585216" cy="475488"/>
+          </a:xfrm>
+          <a:prstGeom prst="rect">
+            <a:avLst/>
+          </a:prstGeom>
+          <a:extLst>
+            <a:ext uri="{C572A759-6A51-4108-AA02-DFA0A04FC94B}">
+              <ma14:wrappingTextBoxFlag xmlns:ma14="http://schemas.microsoft.com/office/mac/drawingml/2011/main" val="0"/>
+            </a:ext>
+          </a:extLst>
+        </p:spPr>
+        <p:txBody>
+          <a:bodyPr/>
+          <a:lstStyle>
+            <a:lvl1pPr>
+              <a:defRPr sz="2000">
+                <a:solidFill>
+                  <a:srgbClr val="FFFFFF"/>
+                </a:solidFill>
+                <a:latin typeface="Calibri"/>
+                <a:ea typeface="Calibri"/>
+                <a:cs typeface="Calibri"/>
+              </a:defRPr>
+            </a:lvl1pPr>
+          </a:lstStyle>
+          <a:p>
+            <a:pPr algn="ctr"/>
+            <a:fld id="{F7021451-1387-4CA6-816F-3879F97B5CBC}" type="slidenum">
+              <a:rPr b="1" lang="en-US"/>
+              <a:t>51</a:t>
+            </a:fld>
+            <a:endParaRPr lang="en-US"/>
+          </a:p>
+        </p:txBody>
+      </p:sp>
+    </p:spTree>
+  </p:cSld>
+  <p:clrMapOvr>
+    <a:masterClrMapping/>
+  </p:clrMapOvr>
+</p:sld>
+</file>
+
+<file path=ppt/slides/slide52.xml><?xml version="1.0" encoding="utf-8"?>
+<p:sld xmlns:a="http://schemas.openxmlformats.org/drawingml/2006/main" xmlns:r="http://schemas.openxmlformats.org/officeDocument/2006/relationships" xmlns:p="http://schemas.openxmlformats.org/presentationml/2006/main">
+  <p:cSld name="Slide 52">
+    <p:spTree>
+      <p:nvGrpSpPr>
+        <p:cNvPr id="1" name=""/>
+        <p:cNvGrpSpPr/>
+        <p:nvPr/>
+      </p:nvGrpSpPr>
+      <p:grpSpPr>
+        <a:xfrm>
+          <a:off x="0" y="0"/>
+          <a:ext cx="0" cy="0"/>
+          <a:chOff x="0" y="0"/>
+          <a:chExt cx="0" cy="0"/>
+        </a:xfrm>
+      </p:grpSpPr>
+      <p:sp>
+        <p:nvSpPr>
+          <p:cNvPr id="2" name="Text 0"/>
+          <p:cNvSpPr/>
+          <p:nvPr/>
+        </p:nvSpPr>
+        <p:spPr>
+          <a:xfrm>
+            <a:off x="457200" y="713232"/>
+            <a:ext cx="11368735" cy="274320"/>
+          </a:xfrm>
+          <a:prstGeom prst="rect">
+            <a:avLst/>
+          </a:prstGeom>
+          <a:noFill/>
+          <a:ln/>
+        </p:spPr>
+        <p:txBody>
+          <a:bodyPr wrap="square" lIns="0" tIns="0" rIns="0" bIns="0" rtlCol="0" anchor="ctr"/>
+          <a:lstStyle/>
+          <a:p>
+            <a:pPr algn="r" indent="0" marL="0">
+              <a:buNone/>
+            </a:pPr>
+            <a:r>
+              <a:rPr lang="en-US" sz="1400" b="1" dirty="0">
+                <a:solidFill>
+                  <a:srgbClr val="1C3F6E"/>
+                </a:solidFill>
+                <a:latin typeface="Calibri" pitchFamily="34" charset="0"/>
+                <a:ea typeface="Calibri" pitchFamily="34" charset="-122"/>
+                <a:cs typeface="Calibri" pitchFamily="34" charset="-120"/>
+              </a:rPr>
               <a:t>BILINGUAL GAME</a:t>
             </a:r>
             <a:endParaRPr lang="en-US" sz="1400" dirty="0"/>
@@ -17287,7 +18773,7 @@
       </p:sp>
       <p:graphicFrame>
         <p:nvGraphicFramePr>
-          <p:cNvPr id="50" name="Table 0"/>
+          <p:cNvPr id="53" name="Table 0"/>
           <p:cNvGraphicFramePr>
             <a:graphicFrameLocks noGrp="1"/>
           </p:cNvGraphicFramePr>
@@ -18323,7 +19809,7 @@
             <a:pPr algn="ctr"/>
             <a:fld id="{F7021451-1387-4CA6-816F-3879F97B5CBC}" type="slidenum">
               <a:rPr b="1" lang="en-US"/>
-              <a:t>49</a:t>
+              <a:t>52</a:t>
             </a:fld>
             <a:endParaRPr lang="en-US"/>
           </a:p>
@@ -18337,9 +19823,9 @@
 </p:sld>
 </file>
 
-<file path=ppt/slides/slide5.xml><?xml version="1.0" encoding="utf-8"?>
+<file path=ppt/slides/slide53.xml><?xml version="1.0" encoding="utf-8"?>
 <p:sld xmlns:a="http://schemas.openxmlformats.org/drawingml/2006/main" xmlns:r="http://schemas.openxmlformats.org/officeDocument/2006/relationships" xmlns:p="http://schemas.openxmlformats.org/presentationml/2006/main">
-  <p:cSld name="Slide 5">
+  <p:cSld name="Slide 53">
     <p:spTree>
       <p:nvGrpSpPr>
         <p:cNvPr id="1" name=""/>
@@ -18387,225 +19873,6 @@
                 <a:ea typeface="Calibri" pitchFamily="34" charset="-122"/>
                 <a:cs typeface="Calibri" pitchFamily="34" charset="-120"/>
               </a:rPr>
-              <a:t>HOMEWORK CORRECTION</a:t>
-            </a:r>
-            <a:endParaRPr lang="en-US" sz="1400" dirty="0"/>
-          </a:p>
-        </p:txBody>
-      </p:sp>
-      <p:pic>
-        <p:nvPicPr>
-          <p:cNvPr id="3" name="Image 0" descr="/home/claude/f4/img/minesec_sheet.png">    </p:cNvPr>
-          <p:cNvPicPr>
-            <a:picLocks noChangeAspect="1"/>
-          </p:cNvPicPr>
-          <p:nvPr/>
-        </p:nvPicPr>
-        <p:blipFill>
-          <a:blip r:embed="rId1"/>
-          <a:stretch>
-            <a:fillRect/>
-          </a:stretch>
-        </p:blipFill>
-        <p:spPr>
-          <a:xfrm>
-            <a:off x="0" y="658368"/>
-            <a:ext cx="5120640" cy="5833872"/>
-          </a:xfrm>
-          <a:prstGeom prst="rect">
-            <a:avLst/>
-          </a:prstGeom>
-        </p:spPr>
-      </p:pic>
-      <p:sp>
-        <p:nvSpPr>
-          <p:cNvPr id="4" name="Text 1"/>
-          <p:cNvSpPr/>
-          <p:nvPr/>
-        </p:nvSpPr>
-        <p:spPr>
-          <a:xfrm>
-            <a:off x="5349240" y="1005840"/>
-            <a:ext cx="6522415" cy="731520"/>
-          </a:xfrm>
-          <a:prstGeom prst="rect">
-            <a:avLst/>
-          </a:prstGeom>
-          <a:noFill/>
-          <a:ln/>
-        </p:spPr>
-        <p:txBody>
-          <a:bodyPr wrap="square" lIns="0" tIns="0" rIns="0" bIns="0" rtlCol="0" anchor="ctr">
-            <a:normAutofit/>
-          </a:bodyPr>
-          <a:lstStyle/>
-          <a:p>
-            <a:pPr algn="ctr" indent="0" marL="0">
-              <a:buNone/>
-            </a:pPr>
-            <a:r>
-              <a:rPr lang="en-US" sz="3600" b="1" dirty="0">
-                <a:solidFill>
-                  <a:srgbClr val="990011"/>
-                </a:solidFill>
-                <a:latin typeface="Times New Roman" pitchFamily="34" charset="0"/>
-                <a:ea typeface="Times New Roman" pitchFamily="34" charset="-122"/>
-                <a:cs typeface="Times New Roman" pitchFamily="34" charset="-120"/>
-              </a:rPr>
-              <a:t>Correction: Possible Answer</a:t>
-            </a:r>
-            <a:endParaRPr lang="en-US" sz="3600" dirty="0"/>
-          </a:p>
-        </p:txBody>
-      </p:sp>
-      <p:sp>
-        <p:nvSpPr>
-          <p:cNvPr id="5" name="Text 2"/>
-          <p:cNvSpPr/>
-          <p:nvPr/>
-        </p:nvSpPr>
-        <p:spPr>
-          <a:xfrm>
-            <a:off x="5349240" y="1783080"/>
-            <a:ext cx="6522415" cy="4663440"/>
-          </a:xfrm>
-          <a:prstGeom prst="rect">
-            <a:avLst/>
-          </a:prstGeom>
-          <a:noFill/>
-          <a:ln/>
-        </p:spPr>
-        <p:txBody>
-          <a:bodyPr wrap="square" lIns="0" tIns="0" rIns="0" bIns="0" rtlCol="0" anchor="t"/>
-          <a:lstStyle/>
-          <a:p>
-            <a:pPr algn="l" indent="0" marL="0">
-              <a:spcAft>
-                <a:spcPts val="800"/>
-              </a:spcAft>
-              <a:buNone/>
-            </a:pPr>
-            <a:r>
-              <a:rPr lang="en-US" sz="4000" dirty="0">
-                <a:solidFill>
-                  <a:srgbClr val="111111"/>
-                </a:solidFill>
-                <a:latin typeface="Times New Roman" pitchFamily="34" charset="0"/>
-                <a:ea typeface="Times New Roman" pitchFamily="34" charset="-122"/>
-                <a:cs typeface="Times New Roman" pitchFamily="34" charset="-120"/>
-              </a:rPr>
-              <a:t>Garoua is 15° east of London, so it is 1 hour ahead: 12:00 + 1 hour = 13:00.</a:t>
-            </a:r>
-            <a:endParaRPr lang="en-US" sz="4000" dirty="0"/>
-          </a:p>
-        </p:txBody>
-      </p:sp>
-      <p:sp>
-        <p:nvSpPr>
-          <p:cNvPr id="25" name="Slide Number Placeholder 0"/>
-          <p:cNvSpPr>
-            <a:spLocks noGrp="1"/>
-          </p:cNvSpPr>
-          <p:nvPr>
-            <p:ph type="sldNum" sz="quarter" idx="4294967295"/>
-          </p:nvPr>
-        </p:nvSpPr>
-        <p:spPr>
-          <a:xfrm>
-            <a:off x="27432" y="91440"/>
-            <a:ext cx="585216" cy="475488"/>
-          </a:xfrm>
-          <a:prstGeom prst="rect">
-            <a:avLst/>
-          </a:prstGeom>
-          <a:extLst>
-            <a:ext uri="{C572A759-6A51-4108-AA02-DFA0A04FC94B}">
-              <ma14:wrappingTextBoxFlag xmlns:ma14="http://schemas.microsoft.com/office/mac/drawingml/2011/main" val="0"/>
-            </a:ext>
-          </a:extLst>
-        </p:spPr>
-        <p:txBody>
-          <a:bodyPr/>
-          <a:lstStyle>
-            <a:lvl1pPr>
-              <a:defRPr sz="2000">
-                <a:solidFill>
-                  <a:srgbClr val="FFFFFF"/>
-                </a:solidFill>
-                <a:latin typeface="Calibri"/>
-                <a:ea typeface="Calibri"/>
-                <a:cs typeface="Calibri"/>
-              </a:defRPr>
-            </a:lvl1pPr>
-          </a:lstStyle>
-          <a:p>
-            <a:pPr algn="ctr"/>
-            <a:fld id="{F7021451-1387-4CA6-816F-3879F97B5CBC}" type="slidenum">
-              <a:rPr b="1" lang="en-US"/>
-              <a:t>5</a:t>
-            </a:fld>
-            <a:endParaRPr lang="en-US"/>
-          </a:p>
-        </p:txBody>
-      </p:sp>
-    </p:spTree>
-  </p:cSld>
-  <p:clrMapOvr>
-    <a:masterClrMapping/>
-  </p:clrMapOvr>
-</p:sld>
-</file>
-
-<file path=ppt/slides/slide50.xml><?xml version="1.0" encoding="utf-8"?>
-<p:sld xmlns:a="http://schemas.openxmlformats.org/drawingml/2006/main" xmlns:r="http://schemas.openxmlformats.org/officeDocument/2006/relationships" xmlns:p="http://schemas.openxmlformats.org/presentationml/2006/main">
-  <p:cSld name="Slide 50">
-    <p:spTree>
-      <p:nvGrpSpPr>
-        <p:cNvPr id="1" name=""/>
-        <p:cNvGrpSpPr/>
-        <p:nvPr/>
-      </p:nvGrpSpPr>
-      <p:grpSpPr>
-        <a:xfrm>
-          <a:off x="0" y="0"/>
-          <a:ext cx="0" cy="0"/>
-          <a:chOff x="0" y="0"/>
-          <a:chExt cx="0" cy="0"/>
-        </a:xfrm>
-      </p:grpSpPr>
-      <p:sp>
-        <p:nvSpPr>
-          <p:cNvPr id="2" name="Text 0"/>
-          <p:cNvSpPr/>
-          <p:nvPr/>
-        </p:nvSpPr>
-        <p:spPr>
-          <a:xfrm>
-            <a:off x="457200" y="713232"/>
-            <a:ext cx="11368735" cy="274320"/>
-          </a:xfrm>
-          <a:prstGeom prst="rect">
-            <a:avLst/>
-          </a:prstGeom>
-          <a:noFill/>
-          <a:ln/>
-        </p:spPr>
-        <p:txBody>
-          <a:bodyPr wrap="square" lIns="0" tIns="0" rIns="0" bIns="0" rtlCol="0" anchor="ctr"/>
-          <a:lstStyle/>
-          <a:p>
-            <a:pPr algn="r" indent="0" marL="0">
-              <a:buNone/>
-            </a:pPr>
-            <a:r>
-              <a:rPr lang="en-US" sz="1400" b="1" dirty="0">
-                <a:solidFill>
-                  <a:srgbClr val="1C3F6E"/>
-                </a:solidFill>
-                <a:latin typeface="Calibri" pitchFamily="34" charset="0"/>
-                <a:ea typeface="Calibri" pitchFamily="34" charset="-122"/>
-                <a:cs typeface="Calibri" pitchFamily="34" charset="-120"/>
-              </a:rPr>
               <a:t>LOGBOOK</a:t>
             </a:r>
             <a:endParaRPr lang="en-US" sz="1400" dirty="0"/>
@@ -18653,7 +19920,7 @@
       </p:sp>
       <p:graphicFrame>
         <p:nvGraphicFramePr>
-          <p:cNvPr id="51" name="Table 0"/>
+          <p:cNvPr id="54" name="Table 0"/>
           <p:cNvGraphicFramePr>
             <a:graphicFrameLocks noGrp="1"/>
           </p:cNvGraphicFramePr>
@@ -19039,7 +20306,7 @@
                           <a:ea typeface="Calibri" pitchFamily="34" charset="-122"/>
                           <a:cs typeface="Calibri" pitchFamily="34" charset="-120"/>
                         </a:rPr>
-                        <a:t>Recall local time, standard time and GMT. Calculate the local time of a place from its longitude. Compare the standard time of Cameroon with other countries.</a:t>
+                        <a:t>Recall local time, standard time and GMT. Calculate the local time of a place from its longitude or from GMT. Compare the standard time of Cameroon with other countries.</a:t>
                       </a:r>
                       <a:endParaRPr lang="en-US" sz="1600" dirty="0">
                         <a:latin typeface="Calibri" charset="0"/>
@@ -19275,7 +20542,7 @@
             <a:pPr algn="ctr"/>
             <a:fld id="{F7021451-1387-4CA6-816F-3879F97B5CBC}" type="slidenum">
               <a:rPr b="1" lang="en-US"/>
-              <a:t>50</a:t>
+              <a:t>53</a:t>
             </a:fld>
             <a:endParaRPr lang="en-US"/>
           </a:p>
@@ -19289,9 +20556,9 @@
 </p:sld>
 </file>
 
-<file path=ppt/slides/slide51.xml><?xml version="1.0" encoding="utf-8"?>
+<file path=ppt/slides/slide54.xml><?xml version="1.0" encoding="utf-8"?>
 <p:sld xmlns:a="http://schemas.openxmlformats.org/drawingml/2006/main" xmlns:r="http://schemas.openxmlformats.org/officeDocument/2006/relationships" xmlns:p="http://schemas.openxmlformats.org/presentationml/2006/main">
-  <p:cSld name="Slide 51">
+  <p:cSld name="Slide 54">
     <p:spTree>
       <p:nvGrpSpPr>
         <p:cNvPr id="1" name=""/>
@@ -19386,7 +20653,7 @@
       </p:sp>
       <p:graphicFrame>
         <p:nvGraphicFramePr>
-          <p:cNvPr id="52" name="Table 0"/>
+          <p:cNvPr id="55" name="Table 0"/>
           <p:cNvGraphicFramePr>
             <a:graphicFrameLocks noGrp="1"/>
           </p:cNvGraphicFramePr>
@@ -19496,7 +20763,7 @@
                           <a:ea typeface="Calibri" pitchFamily="34" charset="-122"/>
                           <a:cs typeface="Calibri" pitchFamily="34" charset="-120"/>
                         </a:rPr>
-                        <a:t>DEFINITIONS; Rules for Calculating Time; Time Zones and Cameroon's Standard Time.</a:t>
+                        <a:t>DEFINITIONS; Rules for Calculating Local Time; Calculating Local Time from GMT; Basis of Time Zones; Cameroon's Standard Time and Other Areas.</a:t>
                       </a:r>
                       <a:endParaRPr lang="en-US" sz="1600" dirty="0">
                         <a:latin typeface="Calibri" charset="0"/>
@@ -20146,7 +21413,7 @@
             <a:pPr algn="ctr"/>
             <a:fld id="{F7021451-1387-4CA6-816F-3879F97B5CBC}" type="slidenum">
               <a:rPr b="1" lang="en-US"/>
-              <a:t>51</a:t>
+              <a:t>54</a:t>
             </a:fld>
             <a:endParaRPr lang="en-US"/>
           </a:p>
@@ -20160,9 +21427,9 @@
 </p:sld>
 </file>
 
-<file path=ppt/slides/slide52.xml><?xml version="1.0" encoding="utf-8"?>
+<file path=ppt/slides/slide55.xml><?xml version="1.0" encoding="utf-8"?>
 <p:sld xmlns:a="http://schemas.openxmlformats.org/drawingml/2006/main" xmlns:r="http://schemas.openxmlformats.org/officeDocument/2006/relationships" xmlns:p="http://schemas.openxmlformats.org/presentationml/2006/main">
-  <p:cSld name="Slide 52">
+  <p:cSld name="Slide 55">
     <p:spTree>
       <p:nvGrpSpPr>
         <p:cNvPr id="1" name=""/>
@@ -20423,7 +21690,7 @@
                 <a:ea typeface="Calibri" pitchFamily="34" charset="-122"/>
                 <a:cs typeface="Calibri" pitchFamily="34" charset="-120"/>
               </a:rPr>
-              <a:t>Without the projector (Activity 5): draw three clocks on the board.</a:t>
+              <a:t>Without the projector (Activity 5): draw two clocks on the board.</a:t>
             </a:r>
             <a:endParaRPr lang="en-US" sz="2000" dirty="0"/>
           </a:p>
@@ -20471,7 +21738,7 @@
             <a:pPr algn="ctr"/>
             <a:fld id="{F7021451-1387-4CA6-816F-3879F97B5CBC}" type="slidenum">
               <a:rPr b="1" lang="en-US"/>
-              <a:t>52</a:t>
+              <a:t>55</a:t>
             </a:fld>
             <a:endParaRPr lang="en-US"/>
           </a:p>
@@ -20485,9 +21752,9 @@
 </p:sld>
 </file>
 
-<file path=ppt/slides/slide53.xml><?xml version="1.0" encoding="utf-8"?>
+<file path=ppt/slides/slide56.xml><?xml version="1.0" encoding="utf-8"?>
 <p:sld xmlns:a="http://schemas.openxmlformats.org/drawingml/2006/main" xmlns:r="http://schemas.openxmlformats.org/officeDocument/2006/relationships" xmlns:p="http://schemas.openxmlformats.org/presentationml/2006/main">
-  <p:cSld name="Slide 53">
+  <p:cSld name="Slide 56">
     <p:spTree>
       <p:nvGrpSpPr>
         <p:cNvPr id="1" name=""/>
@@ -20733,7 +22000,7 @@
             <a:pPr algn="ctr"/>
             <a:fld id="{F7021451-1387-4CA6-816F-3879F97B5CBC}" type="slidenum">
               <a:rPr b="1" lang="en-US"/>
-              <a:t>53</a:t>
+              <a:t>56</a:t>
             </a:fld>
             <a:endParaRPr lang="en-US"/>
           </a:p>
@@ -21279,7 +22546,7 @@
                 <a:ea typeface="Times New Roman" pitchFamily="34" charset="-122"/>
                 <a:cs typeface="Times New Roman" pitchFamily="34" charset="-120"/>
               </a:rPr>
-              <a:t>Calculate the local time of a place from its longitude.</a:t>
+              <a:t>Calculate the local time of a place from its longitude or from GMT.</a:t>
             </a:r>
             <a:endParaRPr lang="en-US" sz="4000" dirty="0"/>
           </a:p>

</xml_diff>